<commit_message>
Update slide deck and docs for the GitOps flow
</commit_message>
<xml_diff>
--- a/demo/ClinicQ-DevOps-Capstone.pptx
+++ b/demo/ClinicQ-DevOps-Capstone.pptx
@@ -23,9 +23,10 @@
     <p:sldId id="271" r:id="rId17"/>
     <p:sldId id="272" r:id="rId18"/>
     <p:sldId id="273" r:id="rId19"/>
+    <p:sldId id="274" r:id="rId20"/>
   </p:sldIdLst>
   <p:notesMasterIdLst>
-    <p:notesMasterId r:id="rId20"/>
+    <p:notesMasterId r:id="rId21"/>
   </p:notesMasterIdLst>
   <p:sldSz cx="12192000" cy="6858000"/>
   <p:notesSz cx="6858000" cy="12192000"/>
@@ -124,46 +125,47 @@
   <p:extLst>
     <p:ext uri="{521415D9-36F7-43E2-AB2F-B90AF26B5E84}">
       <p14:sectionLst xmlns:p14="http://schemas.microsoft.com/office/powerpoint/2010/main">
-        <p14:section name="Intro" id="{89754507-b461-45f4-ea7b-9233e2da25af}">
+        <p14:section name="Intro" id="{0c85a924-25bf-4f1e-2e8f-6a004560bf28}">
           <p14:sldIdLst>
             <p14:sldId id="256"/>
             <p14:sldId id="257"/>
             <p14:sldId id="258"/>
           </p14:sldIdLst>
         </p14:section>
-        <p14:section name="Application and quality" id="{684a045d-07f4-591e-70b7-4b0c05c25fa5}">
+        <p14:section name="Application and quality" id="{7da53125-73b5-5830-6dba-cd10dab411f9}">
           <p14:sldIdLst>
             <p14:sldId id="259"/>
             <p14:sldId id="260"/>
             <p14:sldId id="261"/>
           </p14:sldIdLst>
         </p14:section>
-        <p14:section name="Delivery" id="{5ec64454-98e2-9d94-3e7c-72716b140644}">
+        <p14:section name="Delivery" id="{d263566b-ce9e-26cb-33b3-c2e3b30ca458}">
           <p14:sldIdLst>
             <p14:sldId id="262"/>
             <p14:sldId id="263"/>
             <p14:sldId id="264"/>
           </p14:sldIdLst>
         </p14:section>
-        <p14:section name="Infrastructure" id="{b8d76bfa-a1ff-0e8d-cbeb-6750649e1350}">
+        <p14:section name="Infrastructure" id="{ca5d86b6-56ee-917d-34b8-6b4630649f3d}">
           <p14:sldIdLst>
             <p14:sldId id="265"/>
             <p14:sldId id="266"/>
           </p14:sldIdLst>
         </p14:section>
-        <p14:section name="Operations" id="{f420a98d-2c52-0456-90e8-9d53ff5bf583}">
+        <p14:section name="Operations" id="{aa3184fc-040b-5f2f-564a-f2d1bb0f262a}">
           <p14:sldIdLst>
             <p14:sldId id="267"/>
             <p14:sldId id="268"/>
             <p14:sldId id="269"/>
             <p14:sldId id="270"/>
             <p14:sldId id="271"/>
+            <p14:sldId id="272"/>
           </p14:sldIdLst>
         </p14:section>
-        <p14:section name="Wrap-up" id="{2844fb4e-0668-6304-caad-1e0a063ae8a8}">
+        <p14:section name="Wrap-up" id="{e212f723-629e-1770-fb98-eb268d842f64}">
           <p14:sldIdLst>
-            <p14:sldId id="272"/>
             <p14:sldId id="273"/>
+            <p14:sldId id="274"/>
           </p14:sldIdLst>
         </p14:section>
       </p14:sectionLst>
@@ -1010,7 +1012,7 @@
           <a:p>
             <a:r>
               <a:rPr lang="en-US" dirty="0"/>
-              <a:t>The backend exposes metrics, a ServiceMonitor tells Prometheus to scrape both pods, and Grafana shows request rate by endpoint, p95 latency, 5xx errors, bookings and cancellations from a custom counter, pod count and CPU.</a:t>
+              <a:t>This is the GitOps flow. A push to main runs the pipeline; its last job commits the new image tag into the Helm values file in Git; ArgoCD sees that commit and rolls the cluster forward. In ArgoCD the clinicq application is Healthy and Synced, and the last sync is the commit made by github-actions with the new tag. The cluster changes only through Git, with prune and self-heal on, so manual drift is reverted.</a:t>
             </a:r>
             <a:endParaRPr lang="en-US" dirty="0"/>
           </a:p>
@@ -1098,7 +1100,7 @@
           <a:p>
             <a:r>
               <a:rPr lang="en-US" dirty="0"/>
-              <a:t>These are the real failures during deployment, each diagnosed from events and describe output. They are documented in the repo so they stay fixed in code: the Terraform and StorageClass changes are committed.</a:t>
+              <a:t>The backend exposes metrics, a ServiceMonitor tells Prometheus to scrape both pods, and Grafana shows request rate by endpoint, p95 latency, 5xx errors, bookings and cancellations from a custom counter, pod count and CPU.</a:t>
             </a:r>
             <a:endParaRPr lang="en-US" dirty="0"/>
           </a:p>
@@ -1186,7 +1188,7 @@
           <a:p>
             <a:r>
               <a:rPr lang="en-US" dirty="0"/>
-              <a:t>Three deliberately broken manifests live in the troubleshooting folder. The live demo applies one, reads the symptom, follows the diagnosis commands, and fixes it. The key lesson for the Service case: no matching labels means no endpoints means no traffic.</a:t>
+              <a:t>These are the real failures during deployment, each diagnosed from events and describe output. They are documented in the repo so they stay fixed in code: the Terraform and StorageClass changes are committed.</a:t>
             </a:r>
             <a:endParaRPr lang="en-US" dirty="0"/>
           </a:p>
@@ -1274,7 +1276,7 @@
           <a:p>
             <a:r>
               <a:rPr lang="en-US" dirty="0"/>
-              <a:t>Be upfront about the limits: the load balancer restriction and the conditional deploy job. Then the next steps I would take for production.</a:t>
+              <a:t>Three deliberately broken manifests live in the troubleshooting folder. The live demo applies one, reads the symptom, follows the diagnosis commands, and fixes it. The key lesson for the Service case: no matching labels means no endpoints means no traffic.</a:t>
             </a:r>
             <a:endParaRPr lang="en-US" dirty="0"/>
           </a:p>
@@ -1362,7 +1364,7 @@
           <a:p>
             <a:r>
               <a:rPr lang="en-US" dirty="0"/>
-              <a:t>Run the live demo: small UI change, commit, push, watch the pipeline, deploy the new SHA with Helm, refresh through the Ingress, show Grafana, then break and fix a Service. Close by pointing at the repo.</a:t>
+              <a:t>Be upfront about the limits. Then the next steps I would take for production.</a:t>
             </a:r>
             <a:endParaRPr lang="en-US" dirty="0"/>
           </a:p>
@@ -1386,6 +1388,94 @@
             <a:fld id="{F7021451-1387-4CA6-816F-3879F97B5CBC}" type="slidenum">
               <a:rPr lang="en-US"/>
               <a:t>18</a:t>
+            </a:fld>
+            <a:endParaRPr lang="en-US"/>
+          </a:p>
+        </p:txBody>
+      </p:sp>
+    </p:spTree>
+    <p:extLst>
+      <p:ext uri="{BB962C8B-B14F-4D97-AF65-F5344CB8AC3E}">
+        <p14:creationId xmlns:p14="http://schemas.microsoft.com/office/powerpoint/2010/main" val="1024086991"/>
+      </p:ext>
+    </p:extLst>
+  </p:cSld>
+  <p:clrMapOvr>
+    <a:masterClrMapping/>
+  </p:clrMapOvr>
+</p:notes>
+</file>
+
+<file path=ppt/notesSlides/notesSlide19.xml><?xml version="1.0" encoding="utf-8"?>
+<p:notes xmlns:a="http://schemas.openxmlformats.org/drawingml/2006/main" xmlns:r="http://schemas.openxmlformats.org/officeDocument/2006/relationships" xmlns:p="http://schemas.openxmlformats.org/presentationml/2006/main">
+  <p:cSld>
+    <p:spTree>
+      <p:nvGrpSpPr>
+        <p:cNvPr id="1" name=""/>
+        <p:cNvGrpSpPr/>
+        <p:nvPr/>
+      </p:nvGrpSpPr>
+      <p:grpSpPr>
+        <a:xfrm>
+          <a:off x="0" y="0"/>
+          <a:ext cx="0" cy="0"/>
+          <a:chOff x="0" y="0"/>
+          <a:chExt cx="0" cy="0"/>
+        </a:xfrm>
+      </p:grpSpPr>
+      <p:sp>
+        <p:nvSpPr>
+          <p:cNvPr id="2" name="Slide Image Placeholder 1"/>
+          <p:cNvSpPr>
+            <a:spLocks noGrp="1" noRot="1" noChangeAspect="1"/>
+          </p:cNvSpPr>
+          <p:nvPr>
+            <p:ph type="sldImg"/>
+          </p:nvPr>
+        </p:nvSpPr>
+        <p:spPr/>
+      </p:sp>
+      <p:sp>
+        <p:nvSpPr>
+          <p:cNvPr id="3" name="Notes Placeholder 2"/>
+          <p:cNvSpPr>
+            <a:spLocks noGrp="1"/>
+          </p:cNvSpPr>
+          <p:nvPr>
+            <p:ph type="body" idx="1"/>
+          </p:nvPr>
+        </p:nvSpPr>
+        <p:spPr/>
+        <p:txBody>
+          <a:bodyPr/>
+          <a:lstStyle/>
+          <a:p>
+            <a:r>
+              <a:rPr lang="en-US" dirty="0"/>
+              <a:t>Run the live demo: small UI change, commit, push, watch the pipeline, deploy the new SHA with Helm, refresh through the Ingress, show Grafana, then break and fix a Service. Close by pointing at the repo.</a:t>
+            </a:r>
+            <a:endParaRPr lang="en-US" dirty="0"/>
+          </a:p>
+        </p:txBody>
+      </p:sp>
+      <p:sp>
+        <p:nvSpPr>
+          <p:cNvPr id="4" name="Slide Number Placeholder 3"/>
+          <p:cNvSpPr>
+            <a:spLocks noGrp="1"/>
+          </p:cNvSpPr>
+          <p:nvPr>
+            <p:ph type="sldNum" sz="quarter" idx="10"/>
+          </p:nvPr>
+        </p:nvSpPr>
+        <p:spPr/>
+        <p:txBody>
+          <a:bodyPr/>
+          <a:lstStyle/>
+          <a:p>
+            <a:fld id="{F7021451-1387-4CA6-816F-3879F97B5CBC}" type="slidenum">
+              <a:rPr lang="en-US"/>
+              <a:t>19</a:t>
             </a:fld>
             <a:endParaRPr lang="en-US"/>
           </a:p>
@@ -1538,7 +1628,7 @@
           <a:p>
             <a:r>
               <a:rPr lang="en-US" dirty="0"/>
-              <a:t>Top row is delivery: a push to main runs Actions, which pushes SHA-tagged images to GHCR, then Helm deploys them. Terraform builds the network and cluster underneath. Inside the cluster the Ingress routes slash-api to the backend and everything else to the frontend; the backend talks to PostgreSQL on an EBS volume; Prometheus scrapes the backend and Grafana reads from Prometheus.</a:t>
+              <a:t>Top row is delivery: a push to main runs Actions, which pushes SHA-tagged images to GHCR and commits the new tag to Git; ArgoCD watches the repo and syncs the cluster. Terraform builds the network and cluster underneath. Inside the cluster the Ingress routes slash-api to the backend and everything else to the frontend; the backend talks to PostgreSQL on an EBS volume; Prometheus scrapes the backend and Grafana reads from Prometheus.</a:t>
             </a:r>
             <a:endParaRPr lang="en-US" dirty="0"/>
           </a:p>
@@ -1978,7 +2068,7 @@
           <a:p>
             <a:r>
               <a:rPr lang="en-US" dirty="0"/>
-              <a:t>The pipeline runs on every push to main. Tests gate the build, both images are scanned before they are pushed, and each image is tagged with the commit SHA so a running pod traces back to a commit. The deploy job is conditional on a kubeconfig secret that I did not configure, so I deployed with Helm from my laptop using these same images.</a:t>
+              <a:t>The pipeline runs on every push to main. Tests gate the build, both images are scanned before they are pushed, and each image is tagged with the commit SHA so a running pod traces back to a commit. The last job commits the new tag to the Helm values file in Git, and ArgoCD deploys from there, so the pipeline needs no cluster credentials.</a:t>
             </a:r>
             <a:endParaRPr lang="en-US" dirty="0"/>
           </a:p>
@@ -5289,7 +5379,7 @@
                 <a:ea typeface="Cambria" pitchFamily="34" charset="-122"/>
                 <a:cs typeface="Cambria" pitchFamily="34" charset="-120"/>
               </a:rPr>
-              <a:t>Monitoring</a:t>
+              <a:t>GitOps with ArgoCD</a:t>
             </a:r>
             <a:endParaRPr lang="en-US" sz="3400" dirty="0"/>
           </a:p>
@@ -5347,15 +5437,439 @@
                   <a:schemeClr val="bg1"/>
                 </a:solidFill>
               </a:rPr>
-              <a:t>M9  ·  Observability  ·  10 pts</a:t>
+              <a:t>GitOps  ·  ArgoCD</a:t>
             </a:r>
             <a:endParaRPr lang="en-US" sz="1400" dirty="0"/>
+          </a:p>
+        </p:txBody>
+      </p:sp>
+      <p:sp>
+        <p:nvSpPr>
+          <p:cNvPr id="5" name="step circle 1"/>
+          <p:cNvSpPr/>
+          <p:nvPr/>
+        </p:nvSpPr>
+        <p:spPr>
+          <a:xfrm>
+            <a:off x="548640" y="1463040"/>
+            <a:ext cx="594360" cy="594360"/>
+          </a:xfrm>
+          <a:prstGeom prst="ellipse">
+            <a:avLst/>
+          </a:prstGeom>
+          <a:solidFill>
+            <a:schemeClr val="accent1"/>
+          </a:solidFill>
+          <a:ln/>
+        </p:spPr>
+      </p:sp>
+      <p:sp>
+        <p:nvSpPr>
+          <p:cNvPr id="6" name="step number 1"/>
+          <p:cNvSpPr txBox="1"/>
+          <p:nvPr/>
+        </p:nvSpPr>
+        <p:spPr>
+          <a:xfrm>
+            <a:off x="548640" y="1463040"/>
+            <a:ext cx="594360" cy="594360"/>
+          </a:xfrm>
+          <a:prstGeom prst="rect">
+            <a:avLst/>
+          </a:prstGeom>
+          <a:noFill/>
+          <a:ln/>
+        </p:spPr>
+        <p:txBody>
+          <a:bodyPr wrap="square" lIns="0" tIns="0" rIns="0" bIns="0" rtlCol="0" anchor="ctr"/>
+          <a:lstStyle/>
+          <a:p>
+            <a:pPr algn="ctr" indent="0" marL="0">
+              <a:buNone/>
+            </a:pPr>
+            <a:r>
+              <a:rPr lang="en-US" sz="2000" b="1" dirty="0">
+                <a:solidFill>
+                  <a:schemeClr val="bg1"/>
+                </a:solidFill>
+              </a:rPr>
+              <a:t>1</a:t>
+            </a:r>
+            <a:endParaRPr lang="en-US" sz="2000" dirty="0"/>
+          </a:p>
+        </p:txBody>
+      </p:sp>
+      <p:sp>
+        <p:nvSpPr>
+          <p:cNvPr id="7" name="step text 1"/>
+          <p:cNvSpPr txBox="1"/>
+          <p:nvPr/>
+        </p:nvSpPr>
+        <p:spPr>
+          <a:xfrm>
+            <a:off x="1371600" y="1417320"/>
+            <a:ext cx="3474720" cy="868680"/>
+          </a:xfrm>
+          <a:prstGeom prst="rect">
+            <a:avLst/>
+          </a:prstGeom>
+          <a:noFill/>
+          <a:ln/>
+        </p:spPr>
+        <p:txBody>
+          <a:bodyPr wrap="square" lIns="0" tIns="0" rIns="0" bIns="0" rtlCol="0" anchor="t"/>
+          <a:lstStyle/>
+          <a:p>
+            <a:pPr indent="0" marL="0">
+              <a:buNone/>
+            </a:pPr>
+            <a:r>
+              <a:rPr lang="en-US" sz="1800" b="1" dirty="0">
+                <a:solidFill>
+                  <a:schemeClr val="tx1"/>
+                </a:solidFill>
+              </a:rPr>
+              <a:t>Push to main</a:t>
+            </a:r>
+            <a:endParaRPr lang="en-US" sz="1800" dirty="0"/>
+          </a:p>
+          <a:p>
+            <a:pPr indent="0" marL="0">
+              <a:buNone/>
+            </a:pPr>
+            <a:r>
+              <a:rPr lang="en-US" sz="1400" dirty="0">
+                <a:solidFill>
+                  <a:schemeClr val="accent6"/>
+                </a:solidFill>
+              </a:rPr>
+              <a:t>one commit starts everything</a:t>
+            </a:r>
+            <a:endParaRPr lang="en-US" sz="1800" dirty="0"/>
+          </a:p>
+        </p:txBody>
+      </p:sp>
+      <p:sp>
+        <p:nvSpPr>
+          <p:cNvPr id="8" name="step circle 2"/>
+          <p:cNvSpPr/>
+          <p:nvPr/>
+        </p:nvSpPr>
+        <p:spPr>
+          <a:xfrm>
+            <a:off x="548640" y="2651760"/>
+            <a:ext cx="594360" cy="594360"/>
+          </a:xfrm>
+          <a:prstGeom prst="ellipse">
+            <a:avLst/>
+          </a:prstGeom>
+          <a:solidFill>
+            <a:schemeClr val="accent1"/>
+          </a:solidFill>
+          <a:ln/>
+        </p:spPr>
+      </p:sp>
+      <p:sp>
+        <p:nvSpPr>
+          <p:cNvPr id="9" name="step number 2"/>
+          <p:cNvSpPr txBox="1"/>
+          <p:nvPr/>
+        </p:nvSpPr>
+        <p:spPr>
+          <a:xfrm>
+            <a:off x="548640" y="2651760"/>
+            <a:ext cx="594360" cy="594360"/>
+          </a:xfrm>
+          <a:prstGeom prst="rect">
+            <a:avLst/>
+          </a:prstGeom>
+          <a:noFill/>
+          <a:ln/>
+        </p:spPr>
+        <p:txBody>
+          <a:bodyPr wrap="square" lIns="0" tIns="0" rIns="0" bIns="0" rtlCol="0" anchor="ctr"/>
+          <a:lstStyle/>
+          <a:p>
+            <a:pPr algn="ctr" indent="0" marL="0">
+              <a:buNone/>
+            </a:pPr>
+            <a:r>
+              <a:rPr lang="en-US" sz="2000" b="1" dirty="0">
+                <a:solidFill>
+                  <a:schemeClr val="bg1"/>
+                </a:solidFill>
+              </a:rPr>
+              <a:t>2</a:t>
+            </a:r>
+            <a:endParaRPr lang="en-US" sz="2000" dirty="0"/>
+          </a:p>
+        </p:txBody>
+      </p:sp>
+      <p:sp>
+        <p:nvSpPr>
+          <p:cNvPr id="10" name="step text 2"/>
+          <p:cNvSpPr txBox="1"/>
+          <p:nvPr/>
+        </p:nvSpPr>
+        <p:spPr>
+          <a:xfrm>
+            <a:off x="1371600" y="2606040"/>
+            <a:ext cx="3474720" cy="868680"/>
+          </a:xfrm>
+          <a:prstGeom prst="rect">
+            <a:avLst/>
+          </a:prstGeom>
+          <a:noFill/>
+          <a:ln/>
+        </p:spPr>
+        <p:txBody>
+          <a:bodyPr wrap="square" lIns="0" tIns="0" rIns="0" bIns="0" rtlCol="0" anchor="t"/>
+          <a:lstStyle/>
+          <a:p>
+            <a:pPr indent="0" marL="0">
+              <a:buNone/>
+            </a:pPr>
+            <a:r>
+              <a:rPr lang="en-US" sz="1800" b="1" dirty="0">
+                <a:solidFill>
+                  <a:schemeClr val="tx1"/>
+                </a:solidFill>
+              </a:rPr>
+              <a:t>Actions</a:t>
+            </a:r>
+            <a:endParaRPr lang="en-US" sz="1800" dirty="0"/>
+          </a:p>
+          <a:p>
+            <a:pPr indent="0" marL="0">
+              <a:buNone/>
+            </a:pPr>
+            <a:r>
+              <a:rPr lang="en-US" sz="1400" dirty="0">
+                <a:solidFill>
+                  <a:schemeClr val="accent6"/>
+                </a:solidFill>
+              </a:rPr>
+              <a:t>test, build, scan, push SHA-tagged images</a:t>
+            </a:r>
+            <a:endParaRPr lang="en-US" sz="1800" dirty="0"/>
+          </a:p>
+        </p:txBody>
+      </p:sp>
+      <p:sp>
+        <p:nvSpPr>
+          <p:cNvPr id="11" name="step circle 3"/>
+          <p:cNvSpPr/>
+          <p:nvPr/>
+        </p:nvSpPr>
+        <p:spPr>
+          <a:xfrm>
+            <a:off x="548640" y="3840480"/>
+            <a:ext cx="594360" cy="594360"/>
+          </a:xfrm>
+          <a:prstGeom prst="ellipse">
+            <a:avLst/>
+          </a:prstGeom>
+          <a:solidFill>
+            <a:schemeClr val="accent1"/>
+          </a:solidFill>
+          <a:ln/>
+        </p:spPr>
+      </p:sp>
+      <p:sp>
+        <p:nvSpPr>
+          <p:cNvPr id="12" name="step number 3"/>
+          <p:cNvSpPr txBox="1"/>
+          <p:nvPr/>
+        </p:nvSpPr>
+        <p:spPr>
+          <a:xfrm>
+            <a:off x="548640" y="3840480"/>
+            <a:ext cx="594360" cy="594360"/>
+          </a:xfrm>
+          <a:prstGeom prst="rect">
+            <a:avLst/>
+          </a:prstGeom>
+          <a:noFill/>
+          <a:ln/>
+        </p:spPr>
+        <p:txBody>
+          <a:bodyPr wrap="square" lIns="0" tIns="0" rIns="0" bIns="0" rtlCol="0" anchor="ctr"/>
+          <a:lstStyle/>
+          <a:p>
+            <a:pPr algn="ctr" indent="0" marL="0">
+              <a:buNone/>
+            </a:pPr>
+            <a:r>
+              <a:rPr lang="en-US" sz="2000" b="1" dirty="0">
+                <a:solidFill>
+                  <a:schemeClr val="bg1"/>
+                </a:solidFill>
+              </a:rPr>
+              <a:t>3</a:t>
+            </a:r>
+            <a:endParaRPr lang="en-US" sz="2000" dirty="0"/>
+          </a:p>
+        </p:txBody>
+      </p:sp>
+      <p:sp>
+        <p:nvSpPr>
+          <p:cNvPr id="13" name="step text 3"/>
+          <p:cNvSpPr txBox="1"/>
+          <p:nvPr/>
+        </p:nvSpPr>
+        <p:spPr>
+          <a:xfrm>
+            <a:off x="1371600" y="3794760"/>
+            <a:ext cx="3474720" cy="868680"/>
+          </a:xfrm>
+          <a:prstGeom prst="rect">
+            <a:avLst/>
+          </a:prstGeom>
+          <a:noFill/>
+          <a:ln/>
+        </p:spPr>
+        <p:txBody>
+          <a:bodyPr wrap="square" lIns="0" tIns="0" rIns="0" bIns="0" rtlCol="0" anchor="t"/>
+          <a:lstStyle/>
+          <a:p>
+            <a:pPr indent="0" marL="0">
+              <a:buNone/>
+            </a:pPr>
+            <a:r>
+              <a:rPr lang="en-US" sz="1800" b="1" dirty="0">
+                <a:solidFill>
+                  <a:schemeClr val="tx1"/>
+                </a:solidFill>
+              </a:rPr>
+              <a:t>Commit the tag</a:t>
+            </a:r>
+            <a:endParaRPr lang="en-US" sz="1800" dirty="0"/>
+          </a:p>
+          <a:p>
+            <a:pPr indent="0" marL="0">
+              <a:buNone/>
+            </a:pPr>
+            <a:r>
+              <a:rPr lang="en-US" sz="1400" dirty="0">
+                <a:solidFill>
+                  <a:schemeClr val="accent6"/>
+                </a:solidFill>
+              </a:rPr>
+              <a:t>pipeline writes the SHA into values-prod.yaml</a:t>
+            </a:r>
+            <a:endParaRPr lang="en-US" sz="1800" dirty="0"/>
+          </a:p>
+        </p:txBody>
+      </p:sp>
+      <p:sp>
+        <p:nvSpPr>
+          <p:cNvPr id="14" name="step circle 4"/>
+          <p:cNvSpPr/>
+          <p:nvPr/>
+        </p:nvSpPr>
+        <p:spPr>
+          <a:xfrm>
+            <a:off x="548640" y="5029200"/>
+            <a:ext cx="594360" cy="594360"/>
+          </a:xfrm>
+          <a:prstGeom prst="ellipse">
+            <a:avLst/>
+          </a:prstGeom>
+          <a:solidFill>
+            <a:schemeClr val="accent1"/>
+          </a:solidFill>
+          <a:ln/>
+        </p:spPr>
+      </p:sp>
+      <p:sp>
+        <p:nvSpPr>
+          <p:cNvPr id="15" name="step number 4"/>
+          <p:cNvSpPr txBox="1"/>
+          <p:nvPr/>
+        </p:nvSpPr>
+        <p:spPr>
+          <a:xfrm>
+            <a:off x="548640" y="5029200"/>
+            <a:ext cx="594360" cy="594360"/>
+          </a:xfrm>
+          <a:prstGeom prst="rect">
+            <a:avLst/>
+          </a:prstGeom>
+          <a:noFill/>
+          <a:ln/>
+        </p:spPr>
+        <p:txBody>
+          <a:bodyPr wrap="square" lIns="0" tIns="0" rIns="0" bIns="0" rtlCol="0" anchor="ctr"/>
+          <a:lstStyle/>
+          <a:p>
+            <a:pPr algn="ctr" indent="0" marL="0">
+              <a:buNone/>
+            </a:pPr>
+            <a:r>
+              <a:rPr lang="en-US" sz="2000" b="1" dirty="0">
+                <a:solidFill>
+                  <a:schemeClr val="bg1"/>
+                </a:solidFill>
+              </a:rPr>
+              <a:t>4</a:t>
+            </a:r>
+            <a:endParaRPr lang="en-US" sz="2000" dirty="0"/>
+          </a:p>
+        </p:txBody>
+      </p:sp>
+      <p:sp>
+        <p:nvSpPr>
+          <p:cNvPr id="16" name="step text 4"/>
+          <p:cNvSpPr txBox="1"/>
+          <p:nvPr/>
+        </p:nvSpPr>
+        <p:spPr>
+          <a:xfrm>
+            <a:off x="1371600" y="4983480"/>
+            <a:ext cx="3474720" cy="868680"/>
+          </a:xfrm>
+          <a:prstGeom prst="rect">
+            <a:avLst/>
+          </a:prstGeom>
+          <a:noFill/>
+          <a:ln/>
+        </p:spPr>
+        <p:txBody>
+          <a:bodyPr wrap="square" lIns="0" tIns="0" rIns="0" bIns="0" rtlCol="0" anchor="t"/>
+          <a:lstStyle/>
+          <a:p>
+            <a:pPr indent="0" marL="0">
+              <a:buNone/>
+            </a:pPr>
+            <a:r>
+              <a:rPr lang="en-US" sz="1800" b="1" dirty="0">
+                <a:solidFill>
+                  <a:schemeClr val="tx1"/>
+                </a:solidFill>
+              </a:rPr>
+              <a:t>ArgoCD syncs</a:t>
+            </a:r>
+            <a:endParaRPr lang="en-US" sz="1800" dirty="0"/>
+          </a:p>
+          <a:p>
+            <a:pPr indent="0" marL="0">
+              <a:buNone/>
+            </a:pPr>
+            <a:r>
+              <a:rPr lang="en-US" sz="1400" dirty="0">
+                <a:solidFill>
+                  <a:schemeClr val="accent6"/>
+                </a:solidFill>
+              </a:rPr>
+              <a:t>cluster follows Git: Synced and Healthy</a:t>
+            </a:r>
+            <a:endParaRPr lang="en-US" sz="1800" dirty="0"/>
           </a:p>
         </p:txBody>
       </p:sp>
       <p:pic>
         <p:nvPicPr>
-          <p:cNvPr id="5" name="grafana" descr="Grafana: request rate, p95 latency, 5xx, bookings, pods, CPU">    </p:cNvPr>
+          <p:cNvPr id="17" name="argocd app" descr="ArgoCD: clinicq Healthy and Synced; last sync is the pipeline's tag commit">    </p:cNvPr>
           <p:cNvPicPr>
             <a:picLocks noChangeAspect="1"/>
           </p:cNvPicPr>
@@ -5369,8 +5883,8 @@
         </p:blipFill>
         <p:spPr>
           <a:xfrm>
-            <a:off x="4937760" y="1449228"/>
-            <a:ext cx="6720840" cy="3410903"/>
+            <a:off x="5120640" y="1772412"/>
+            <a:ext cx="6492240" cy="3678936"/>
           </a:xfrm>
           <a:prstGeom prst="rect">
             <a:avLst/>
@@ -5386,14 +5900,14 @@
       </p:pic>
       <p:sp>
         <p:nvSpPr>
-          <p:cNvPr id="6" name="grafana border"/>
+          <p:cNvPr id="18" name="argocd app border"/>
           <p:cNvSpPr/>
           <p:nvPr/>
         </p:nvSpPr>
         <p:spPr>
           <a:xfrm>
-            <a:off x="4937760" y="1449228"/>
-            <a:ext cx="6720840" cy="3410903"/>
+            <a:off x="5120640" y="1772412"/>
+            <a:ext cx="6492240" cy="3678936"/>
           </a:xfrm>
           <a:prstGeom prst="rect">
             <a:avLst/>
@@ -5408,14 +5922,14 @@
       </p:sp>
       <p:sp>
         <p:nvSpPr>
-          <p:cNvPr id="7" name="grafana caption"/>
+          <p:cNvPr id="19" name="argocd app caption"/>
           <p:cNvSpPr txBox="1"/>
           <p:nvPr/>
         </p:nvSpPr>
         <p:spPr>
           <a:xfrm>
-            <a:off x="4937760" y="4905852"/>
-            <a:ext cx="6720840" cy="274320"/>
+            <a:off x="5120640" y="5497068"/>
+            <a:ext cx="6492240" cy="274320"/>
           </a:xfrm>
           <a:prstGeom prst="rect">
             <a:avLst/>
@@ -5436,223 +5950,9 @@
                   <a:schemeClr val="accent6"/>
                 </a:solidFill>
               </a:rPr>
-              <a:t>Grafana: request rate, p95 latency, 5xx, bookings, pods, CPU</a:t>
+              <a:t>ArgoCD: clinicq Healthy and Synced; last sync is the pipeline's tag commit</a:t>
             </a:r>
             <a:endParaRPr lang="en-US" sz="1200" dirty="0"/>
-          </a:p>
-        </p:txBody>
-      </p:sp>
-      <p:pic>
-        <p:nvPicPr>
-          <p:cNvPr id="8" name="prometheus" descr="Prometheus: clinicq-backend 2/2 UP">    </p:cNvPr>
-          <p:cNvPicPr>
-            <a:picLocks noChangeAspect="1"/>
-          </p:cNvPicPr>
-          <p:nvPr/>
-        </p:nvPicPr>
-        <p:blipFill>
-          <a:blip r:embed="rId2"/>
-          <a:stretch>
-            <a:fillRect/>
-          </a:stretch>
-        </p:blipFill>
-        <p:spPr>
-          <a:xfrm>
-            <a:off x="594533" y="1371600"/>
-            <a:ext cx="4023014" cy="2103120"/>
-          </a:xfrm>
-          <a:prstGeom prst="rect">
-            <a:avLst/>
-          </a:prstGeom>
-          <a:effectLst>
-            <a:outerShdw sx="100000" sy="100000" kx="0" ky="0" algn="bl" rotWithShape="0" blurRad="76200" dist="25400" dir="5400000">
-              <a:srgbClr val="000000">
-                <a:alpha val="18000"/>
-              </a:srgbClr>
-            </a:outerShdw>
-          </a:effectLst>
-        </p:spPr>
-      </p:pic>
-      <p:sp>
-        <p:nvSpPr>
-          <p:cNvPr id="9" name="prometheus border"/>
-          <p:cNvSpPr/>
-          <p:nvPr/>
-        </p:nvSpPr>
-        <p:spPr>
-          <a:xfrm>
-            <a:off x="594533" y="1371600"/>
-            <a:ext cx="4023014" cy="2103120"/>
-          </a:xfrm>
-          <a:prstGeom prst="rect">
-            <a:avLst/>
-          </a:prstGeom>
-          <a:ln w="9525">
-            <a:solidFill>
-              <a:srgbClr val="CBD5E1"/>
-            </a:solidFill>
-            <a:prstDash val="solid"/>
-          </a:ln>
-        </p:spPr>
-      </p:sp>
-      <p:sp>
-        <p:nvSpPr>
-          <p:cNvPr id="10" name="prometheus caption"/>
-          <p:cNvSpPr txBox="1"/>
-          <p:nvPr/>
-        </p:nvSpPr>
-        <p:spPr>
-          <a:xfrm>
-            <a:off x="594533" y="3520440"/>
-            <a:ext cx="4023014" cy="274320"/>
-          </a:xfrm>
-          <a:prstGeom prst="rect">
-            <a:avLst/>
-          </a:prstGeom>
-          <a:noFill/>
-          <a:ln/>
-        </p:spPr>
-        <p:txBody>
-          <a:bodyPr wrap="square" lIns="0" tIns="0" rIns="0" bIns="0" rtlCol="0" anchor="ctr"/>
-          <a:lstStyle/>
-          <a:p>
-            <a:pPr algn="l" indent="0" marL="0">
-              <a:buNone/>
-            </a:pPr>
-            <a:r>
-              <a:rPr lang="en-US" sz="1200" dirty="0">
-                <a:solidFill>
-                  <a:schemeClr val="accent6"/>
-                </a:solidFill>
-              </a:rPr>
-              <a:t>Prometheus: clinicq-backend 2/2 UP</a:t>
-            </a:r>
-            <a:endParaRPr lang="en-US" sz="1200" dirty="0"/>
-          </a:p>
-        </p:txBody>
-      </p:sp>
-      <p:pic>
-        <p:nvPicPr>
-          <p:cNvPr id="11" name="metrics" descr="/metrics in Prometheus format">    </p:cNvPr>
-          <p:cNvPicPr>
-            <a:picLocks noChangeAspect="1"/>
-          </p:cNvPicPr>
-          <p:nvPr/>
-        </p:nvPicPr>
-        <p:blipFill>
-          <a:blip r:embed="rId3"/>
-          <a:stretch>
-            <a:fillRect/>
-          </a:stretch>
-        </p:blipFill>
-        <p:spPr>
-          <a:xfrm>
-            <a:off x="937688" y="3886200"/>
-            <a:ext cx="3336703" cy="1920240"/>
-          </a:xfrm>
-          <a:prstGeom prst="rect">
-            <a:avLst/>
-          </a:prstGeom>
-          <a:effectLst>
-            <a:outerShdw sx="100000" sy="100000" kx="0" ky="0" algn="bl" rotWithShape="0" blurRad="76200" dist="25400" dir="5400000">
-              <a:srgbClr val="000000">
-                <a:alpha val="18000"/>
-              </a:srgbClr>
-            </a:outerShdw>
-          </a:effectLst>
-        </p:spPr>
-      </p:pic>
-      <p:sp>
-        <p:nvSpPr>
-          <p:cNvPr id="12" name="metrics border"/>
-          <p:cNvSpPr/>
-          <p:nvPr/>
-        </p:nvSpPr>
-        <p:spPr>
-          <a:xfrm>
-            <a:off x="937688" y="3886200"/>
-            <a:ext cx="3336703" cy="1920240"/>
-          </a:xfrm>
-          <a:prstGeom prst="rect">
-            <a:avLst/>
-          </a:prstGeom>
-          <a:ln w="9525">
-            <a:solidFill>
-              <a:srgbClr val="CBD5E1"/>
-            </a:solidFill>
-            <a:prstDash val="solid"/>
-          </a:ln>
-        </p:spPr>
-      </p:sp>
-      <p:sp>
-        <p:nvSpPr>
-          <p:cNvPr id="13" name="metrics caption"/>
-          <p:cNvSpPr txBox="1"/>
-          <p:nvPr/>
-        </p:nvSpPr>
-        <p:spPr>
-          <a:xfrm>
-            <a:off x="937688" y="5852160"/>
-            <a:ext cx="3336703" cy="274320"/>
-          </a:xfrm>
-          <a:prstGeom prst="rect">
-            <a:avLst/>
-          </a:prstGeom>
-          <a:noFill/>
-          <a:ln/>
-        </p:spPr>
-        <p:txBody>
-          <a:bodyPr wrap="square" lIns="0" tIns="0" rIns="0" bIns="0" rtlCol="0" anchor="ctr"/>
-          <a:lstStyle/>
-          <a:p>
-            <a:pPr algn="l" indent="0" marL="0">
-              <a:buNone/>
-            </a:pPr>
-            <a:r>
-              <a:rPr lang="en-US" sz="1200" dirty="0">
-                <a:solidFill>
-                  <a:schemeClr val="accent6"/>
-                </a:solidFill>
-              </a:rPr>
-              <a:t>/metrics in Prometheus format</a:t>
-            </a:r>
-            <a:endParaRPr lang="en-US" sz="1200" dirty="0"/>
-          </a:p>
-        </p:txBody>
-      </p:sp>
-      <p:sp>
-        <p:nvSpPr>
-          <p:cNvPr id="14" name="monitoring note"/>
-          <p:cNvSpPr txBox="1"/>
-          <p:nvPr/>
-        </p:nvSpPr>
-        <p:spPr>
-          <a:xfrm>
-            <a:off x="4937760" y="5440680"/>
-            <a:ext cx="6720840" cy="731520"/>
-          </a:xfrm>
-          <a:prstGeom prst="rect">
-            <a:avLst/>
-          </a:prstGeom>
-          <a:noFill/>
-          <a:ln/>
-        </p:spPr>
-        <p:txBody>
-          <a:bodyPr wrap="square" lIns="0" tIns="0" rIns="0" bIns="0" rtlCol="0" anchor="t"/>
-          <a:lstStyle/>
-          <a:p>
-            <a:pPr indent="0" marL="0">
-              <a:buNone/>
-            </a:pPr>
-            <a:r>
-              <a:rPr lang="en-US" sz="1500" dirty="0">
-                <a:solidFill>
-                  <a:schemeClr val="tx1"/>
-                </a:solidFill>
-              </a:rPr>
-              <a:t>A ServiceMonitor tells Prometheus to scrape both backend pods. A custom counter tracks bookings and cancellations.</a:t>
-            </a:r>
-            <a:endParaRPr lang="en-US" sz="1500" dirty="0"/>
           </a:p>
         </p:txBody>
       </p:sp>
@@ -5764,6 +6064,481 @@
                 <a:ea typeface="Cambria" pitchFamily="34" charset="-122"/>
                 <a:cs typeface="Cambria" pitchFamily="34" charset="-120"/>
               </a:rPr>
+              <a:t>Monitoring</a:t>
+            </a:r>
+            <a:endParaRPr lang="en-US" sz="3400" dirty="0"/>
+          </a:p>
+        </p:txBody>
+      </p:sp>
+      <p:sp>
+        <p:nvSpPr>
+          <p:cNvPr id="3" name="module chip"/>
+          <p:cNvSpPr/>
+          <p:nvPr/>
+        </p:nvSpPr>
+        <p:spPr>
+          <a:xfrm>
+            <a:off x="9326880" y="566928"/>
+            <a:ext cx="2331720" cy="402336"/>
+          </a:xfrm>
+          <a:prstGeom prst="roundRect">
+            <a:avLst>
+              <a:gd name="adj" fmla="val 50000"/>
+            </a:avLst>
+          </a:prstGeom>
+          <a:solidFill>
+            <a:schemeClr val="accent1"/>
+          </a:solidFill>
+          <a:ln/>
+        </p:spPr>
+      </p:sp>
+      <p:sp>
+        <p:nvSpPr>
+          <p:cNvPr id="4" name="module chip text"/>
+          <p:cNvSpPr txBox="1"/>
+          <p:nvPr/>
+        </p:nvSpPr>
+        <p:spPr>
+          <a:xfrm>
+            <a:off x="9326880" y="566928"/>
+            <a:ext cx="2331720" cy="402336"/>
+          </a:xfrm>
+          <a:prstGeom prst="rect">
+            <a:avLst/>
+          </a:prstGeom>
+          <a:noFill/>
+          <a:ln/>
+        </p:spPr>
+        <p:txBody>
+          <a:bodyPr wrap="square" lIns="0" tIns="0" rIns="0" bIns="0" rtlCol="0" anchor="ctr"/>
+          <a:lstStyle/>
+          <a:p>
+            <a:pPr algn="ctr" indent="0" marL="0">
+              <a:buNone/>
+            </a:pPr>
+            <a:r>
+              <a:rPr lang="en-US" sz="1400" b="1" dirty="0">
+                <a:solidFill>
+                  <a:schemeClr val="bg1"/>
+                </a:solidFill>
+              </a:rPr>
+              <a:t>M9  ·  Observability  ·  10 pts</a:t>
+            </a:r>
+            <a:endParaRPr lang="en-US" sz="1400" dirty="0"/>
+          </a:p>
+        </p:txBody>
+      </p:sp>
+      <p:pic>
+        <p:nvPicPr>
+          <p:cNvPr id="5" name="grafana" descr="Grafana: request rate, p95 latency, 5xx, bookings, pods, CPU">    </p:cNvPr>
+          <p:cNvPicPr>
+            <a:picLocks noChangeAspect="1"/>
+          </p:cNvPicPr>
+          <p:nvPr/>
+        </p:nvPicPr>
+        <p:blipFill>
+          <a:blip r:embed="rId1"/>
+          <a:stretch>
+            <a:fillRect/>
+          </a:stretch>
+        </p:blipFill>
+        <p:spPr>
+          <a:xfrm>
+            <a:off x="5750923" y="1371600"/>
+            <a:ext cx="5094514" cy="3566160"/>
+          </a:xfrm>
+          <a:prstGeom prst="rect">
+            <a:avLst/>
+          </a:prstGeom>
+          <a:effectLst>
+            <a:outerShdw sx="100000" sy="100000" kx="0" ky="0" algn="bl" rotWithShape="0" blurRad="76200" dist="25400" dir="5400000">
+              <a:srgbClr val="000000">
+                <a:alpha val="18000"/>
+              </a:srgbClr>
+            </a:outerShdw>
+          </a:effectLst>
+        </p:spPr>
+      </p:pic>
+      <p:sp>
+        <p:nvSpPr>
+          <p:cNvPr id="6" name="grafana border"/>
+          <p:cNvSpPr/>
+          <p:nvPr/>
+        </p:nvSpPr>
+        <p:spPr>
+          <a:xfrm>
+            <a:off x="5750923" y="1371600"/>
+            <a:ext cx="5094514" cy="3566160"/>
+          </a:xfrm>
+          <a:prstGeom prst="rect">
+            <a:avLst/>
+          </a:prstGeom>
+          <a:ln w="9525">
+            <a:solidFill>
+              <a:srgbClr val="CBD5E1"/>
+            </a:solidFill>
+            <a:prstDash val="solid"/>
+          </a:ln>
+        </p:spPr>
+      </p:sp>
+      <p:sp>
+        <p:nvSpPr>
+          <p:cNvPr id="7" name="grafana caption"/>
+          <p:cNvSpPr txBox="1"/>
+          <p:nvPr/>
+        </p:nvSpPr>
+        <p:spPr>
+          <a:xfrm>
+            <a:off x="5750923" y="4983480"/>
+            <a:ext cx="5094514" cy="274320"/>
+          </a:xfrm>
+          <a:prstGeom prst="rect">
+            <a:avLst/>
+          </a:prstGeom>
+          <a:noFill/>
+          <a:ln/>
+        </p:spPr>
+        <p:txBody>
+          <a:bodyPr wrap="square" lIns="0" tIns="0" rIns="0" bIns="0" rtlCol="0" anchor="ctr"/>
+          <a:lstStyle/>
+          <a:p>
+            <a:pPr algn="l" indent="0" marL="0">
+              <a:buNone/>
+            </a:pPr>
+            <a:r>
+              <a:rPr lang="en-US" sz="1200" dirty="0">
+                <a:solidFill>
+                  <a:schemeClr val="accent6"/>
+                </a:solidFill>
+              </a:rPr>
+              <a:t>Grafana: request rate, p95 latency, 5xx, bookings, pods, CPU</a:t>
+            </a:r>
+            <a:endParaRPr lang="en-US" sz="1200" dirty="0"/>
+          </a:p>
+        </p:txBody>
+      </p:sp>
+      <p:pic>
+        <p:nvPicPr>
+          <p:cNvPr id="8" name="prometheus" descr="Prometheus: clinicq-backend 2/2 UP">    </p:cNvPr>
+          <p:cNvPicPr>
+            <a:picLocks noChangeAspect="1"/>
+          </p:cNvPicPr>
+          <p:nvPr/>
+        </p:nvPicPr>
+        <p:blipFill>
+          <a:blip r:embed="rId2"/>
+          <a:stretch>
+            <a:fillRect/>
+          </a:stretch>
+        </p:blipFill>
+        <p:spPr>
+          <a:xfrm>
+            <a:off x="750346" y="1371600"/>
+            <a:ext cx="3711388" cy="2103120"/>
+          </a:xfrm>
+          <a:prstGeom prst="rect">
+            <a:avLst/>
+          </a:prstGeom>
+          <a:effectLst>
+            <a:outerShdw sx="100000" sy="100000" kx="0" ky="0" algn="bl" rotWithShape="0" blurRad="76200" dist="25400" dir="5400000">
+              <a:srgbClr val="000000">
+                <a:alpha val="18000"/>
+              </a:srgbClr>
+            </a:outerShdw>
+          </a:effectLst>
+        </p:spPr>
+      </p:pic>
+      <p:sp>
+        <p:nvSpPr>
+          <p:cNvPr id="9" name="prometheus border"/>
+          <p:cNvSpPr/>
+          <p:nvPr/>
+        </p:nvSpPr>
+        <p:spPr>
+          <a:xfrm>
+            <a:off x="750346" y="1371600"/>
+            <a:ext cx="3711388" cy="2103120"/>
+          </a:xfrm>
+          <a:prstGeom prst="rect">
+            <a:avLst/>
+          </a:prstGeom>
+          <a:ln w="9525">
+            <a:solidFill>
+              <a:srgbClr val="CBD5E1"/>
+            </a:solidFill>
+            <a:prstDash val="solid"/>
+          </a:ln>
+        </p:spPr>
+      </p:sp>
+      <p:sp>
+        <p:nvSpPr>
+          <p:cNvPr id="10" name="prometheus caption"/>
+          <p:cNvSpPr txBox="1"/>
+          <p:nvPr/>
+        </p:nvSpPr>
+        <p:spPr>
+          <a:xfrm>
+            <a:off x="750346" y="3520440"/>
+            <a:ext cx="3711388" cy="274320"/>
+          </a:xfrm>
+          <a:prstGeom prst="rect">
+            <a:avLst/>
+          </a:prstGeom>
+          <a:noFill/>
+          <a:ln/>
+        </p:spPr>
+        <p:txBody>
+          <a:bodyPr wrap="square" lIns="0" tIns="0" rIns="0" bIns="0" rtlCol="0" anchor="ctr"/>
+          <a:lstStyle/>
+          <a:p>
+            <a:pPr algn="l" indent="0" marL="0">
+              <a:buNone/>
+            </a:pPr>
+            <a:r>
+              <a:rPr lang="en-US" sz="1200" dirty="0">
+                <a:solidFill>
+                  <a:schemeClr val="accent6"/>
+                </a:solidFill>
+              </a:rPr>
+              <a:t>Prometheus: clinicq-backend 2/2 UP</a:t>
+            </a:r>
+            <a:endParaRPr lang="en-US" sz="1200" dirty="0"/>
+          </a:p>
+        </p:txBody>
+      </p:sp>
+      <p:pic>
+        <p:nvPicPr>
+          <p:cNvPr id="11" name="metrics" descr="/metrics in Prometheus format">    </p:cNvPr>
+          <p:cNvPicPr>
+            <a:picLocks noChangeAspect="1"/>
+          </p:cNvPicPr>
+          <p:nvPr/>
+        </p:nvPicPr>
+        <p:blipFill>
+          <a:blip r:embed="rId3"/>
+          <a:stretch>
+            <a:fillRect/>
+          </a:stretch>
+        </p:blipFill>
+        <p:spPr>
+          <a:xfrm>
+            <a:off x="937688" y="3886200"/>
+            <a:ext cx="3336703" cy="1920240"/>
+          </a:xfrm>
+          <a:prstGeom prst="rect">
+            <a:avLst/>
+          </a:prstGeom>
+          <a:effectLst>
+            <a:outerShdw sx="100000" sy="100000" kx="0" ky="0" algn="bl" rotWithShape="0" blurRad="76200" dist="25400" dir="5400000">
+              <a:srgbClr val="000000">
+                <a:alpha val="18000"/>
+              </a:srgbClr>
+            </a:outerShdw>
+          </a:effectLst>
+        </p:spPr>
+      </p:pic>
+      <p:sp>
+        <p:nvSpPr>
+          <p:cNvPr id="12" name="metrics border"/>
+          <p:cNvSpPr/>
+          <p:nvPr/>
+        </p:nvSpPr>
+        <p:spPr>
+          <a:xfrm>
+            <a:off x="937688" y="3886200"/>
+            <a:ext cx="3336703" cy="1920240"/>
+          </a:xfrm>
+          <a:prstGeom prst="rect">
+            <a:avLst/>
+          </a:prstGeom>
+          <a:ln w="9525">
+            <a:solidFill>
+              <a:srgbClr val="CBD5E1"/>
+            </a:solidFill>
+            <a:prstDash val="solid"/>
+          </a:ln>
+        </p:spPr>
+      </p:sp>
+      <p:sp>
+        <p:nvSpPr>
+          <p:cNvPr id="13" name="metrics caption"/>
+          <p:cNvSpPr txBox="1"/>
+          <p:nvPr/>
+        </p:nvSpPr>
+        <p:spPr>
+          <a:xfrm>
+            <a:off x="937688" y="5852160"/>
+            <a:ext cx="3336703" cy="274320"/>
+          </a:xfrm>
+          <a:prstGeom prst="rect">
+            <a:avLst/>
+          </a:prstGeom>
+          <a:noFill/>
+          <a:ln/>
+        </p:spPr>
+        <p:txBody>
+          <a:bodyPr wrap="square" lIns="0" tIns="0" rIns="0" bIns="0" rtlCol="0" anchor="ctr"/>
+          <a:lstStyle/>
+          <a:p>
+            <a:pPr algn="l" indent="0" marL="0">
+              <a:buNone/>
+            </a:pPr>
+            <a:r>
+              <a:rPr lang="en-US" sz="1200" dirty="0">
+                <a:solidFill>
+                  <a:schemeClr val="accent6"/>
+                </a:solidFill>
+              </a:rPr>
+              <a:t>/metrics in Prometheus format</a:t>
+            </a:r>
+            <a:endParaRPr lang="en-US" sz="1200" dirty="0"/>
+          </a:p>
+        </p:txBody>
+      </p:sp>
+      <p:sp>
+        <p:nvSpPr>
+          <p:cNvPr id="14" name="monitoring note"/>
+          <p:cNvSpPr txBox="1"/>
+          <p:nvPr/>
+        </p:nvSpPr>
+        <p:spPr>
+          <a:xfrm>
+            <a:off x="4937760" y="5440680"/>
+            <a:ext cx="6720840" cy="731520"/>
+          </a:xfrm>
+          <a:prstGeom prst="rect">
+            <a:avLst/>
+          </a:prstGeom>
+          <a:noFill/>
+          <a:ln/>
+        </p:spPr>
+        <p:txBody>
+          <a:bodyPr wrap="square" lIns="0" tIns="0" rIns="0" bIns="0" rtlCol="0" anchor="t"/>
+          <a:lstStyle/>
+          <a:p>
+            <a:pPr indent="0" marL="0">
+              <a:buNone/>
+            </a:pPr>
+            <a:r>
+              <a:rPr lang="en-US" sz="1500" dirty="0">
+                <a:solidFill>
+                  <a:schemeClr val="tx1"/>
+                </a:solidFill>
+              </a:rPr>
+              <a:t>A ServiceMonitor tells Prometheus to scrape both backend pods. A custom counter tracks bookings and cancellations.</a:t>
+            </a:r>
+            <a:endParaRPr lang="en-US" sz="1500" dirty="0"/>
+          </a:p>
+        </p:txBody>
+      </p:sp>
+      <p:sp>
+        <p:nvSpPr>
+          <p:cNvPr id="25" name="Slide Number Placeholder 0"/>
+          <p:cNvSpPr>
+            <a:spLocks noGrp="1"/>
+          </p:cNvSpPr>
+          <p:nvPr>
+            <p:ph type="sldNum" sz="quarter" idx="4294967295"/>
+          </p:nvPr>
+        </p:nvSpPr>
+        <p:spPr>
+          <a:xfrm>
+            <a:off x="11155680" y="6400800"/>
+            <a:ext cx="548640" cy="274320"/>
+          </a:xfrm>
+          <a:prstGeom prst="rect">
+            <a:avLst/>
+          </a:prstGeom>
+          <a:extLst>
+            <a:ext uri="{C572A759-6A51-4108-AA02-DFA0A04FC94B}">
+              <ma14:wrappingTextBoxFlag xmlns:ma14="http://schemas.microsoft.com/office/mac/drawingml/2011/main" val="0"/>
+            </a:ext>
+          </a:extLst>
+        </p:spPr>
+        <p:txBody>
+          <a:bodyPr/>
+          <a:lstStyle>
+            <a:lvl1pPr>
+              <a:defRPr sz="1100">
+                <a:solidFill>
+                  <a:srgbClr val="64748B"/>
+                </a:solidFill>
+                <a:latin typeface="Calibri"/>
+                <a:ea typeface="Calibri"/>
+                <a:cs typeface="Calibri"/>
+              </a:defRPr>
+            </a:lvl1pPr>
+          </a:lstStyle>
+          <a:p>
+            <a:pPr algn="r"/>
+            <a:fld id="{F7021451-1387-4CA6-816F-3879F97B5CBC}" type="slidenum">
+              <a:rPr b="0" lang="en-US"/>
+              <a:t>15</a:t>
+            </a:fld>
+            <a:endParaRPr lang="en-US"/>
+          </a:p>
+        </p:txBody>
+      </p:sp>
+    </p:spTree>
+  </p:cSld>
+  <p:clrMapOvr>
+    <a:masterClrMapping/>
+  </p:clrMapOvr>
+</p:sld>
+</file>
+
+<file path=ppt/slides/slide16.xml><?xml version="1.0" encoding="utf-8"?>
+<p:sld xmlns:a="http://schemas.openxmlformats.org/drawingml/2006/main" xmlns:r="http://schemas.openxmlformats.org/officeDocument/2006/relationships" xmlns:p="http://schemas.openxmlformats.org/presentationml/2006/main">
+  <p:cSld name="Slide 16">
+    <p:spTree>
+      <p:nvGrpSpPr>
+        <p:cNvPr id="1" name=""/>
+        <p:cNvGrpSpPr/>
+        <p:nvPr/>
+      </p:nvGrpSpPr>
+      <p:grpSpPr>
+        <a:xfrm>
+          <a:off x="0" y="0"/>
+          <a:ext cx="0" cy="0"/>
+          <a:chOff x="0" y="0"/>
+          <a:chExt cx="0" cy="0"/>
+        </a:xfrm>
+      </p:grpSpPr>
+      <p:sp>
+        <p:nvSpPr>
+          <p:cNvPr id="2" name="Text 1"/>
+          <p:cNvSpPr/>
+          <p:nvPr>
+            <p:ph idx="101" type="title" hasCustomPrompt="1"/>
+          </p:nvPr>
+        </p:nvSpPr>
+        <p:spPr>
+          <a:xfrm>
+            <a:off x="548640" y="365760"/>
+            <a:ext cx="8595360" cy="822960"/>
+          </a:xfrm>
+          <a:prstGeom prst="rect">
+            <a:avLst/>
+          </a:prstGeom>
+          <a:noFill/>
+          <a:ln/>
+        </p:spPr>
+        <p:txBody>
+          <a:bodyPr wrap="square" lIns="0" tIns="0" rIns="0" bIns="0" rtlCol="0" anchor="ctr"/>
+          <a:lstStyle/>
+          <a:p>
+            <a:pPr algn="l" indent="0" marL="0">
+              <a:buNone/>
+            </a:pPr>
+            <a:r>
+              <a:rPr lang="en-US" sz="3400" b="1" dirty="0">
+                <a:solidFill>
+                  <a:schemeClr val="tx1"/>
+                </a:solidFill>
+                <a:latin typeface="Cambria" pitchFamily="34" charset="0"/>
+                <a:ea typeface="Cambria" pitchFamily="34" charset="-122"/>
+                <a:cs typeface="Cambria" pitchFamily="34" charset="-120"/>
+              </a:rPr>
               <a:t>Problems I solved</a:t>
             </a:r>
             <a:endParaRPr lang="en-US" sz="3400" dirty="0"/>
@@ -5772,7 +6547,7 @@
       </p:sp>
       <p:graphicFrame>
         <p:nvGraphicFramePr>
-          <p:cNvPr id="16" name="problems table"/>
+          <p:cNvPr id="17" name="problems table"/>
           <p:cNvGraphicFramePr>
             <a:graphicFrameLocks noGrp="1"/>
           </p:cNvGraphicFramePr>
@@ -7138,876 +7913,6 @@
             <a:pPr algn="r"/>
             <a:fld id="{F7021451-1387-4CA6-816F-3879F97B5CBC}" type="slidenum">
               <a:rPr b="0" lang="en-US"/>
-              <a:t>15</a:t>
-            </a:fld>
-            <a:endParaRPr lang="en-US"/>
-          </a:p>
-        </p:txBody>
-      </p:sp>
-    </p:spTree>
-  </p:cSld>
-  <p:clrMapOvr>
-    <a:masterClrMapping/>
-  </p:clrMapOvr>
-</p:sld>
-</file>
-
-<file path=ppt/slides/slide16.xml><?xml version="1.0" encoding="utf-8"?>
-<p:sld xmlns:a="http://schemas.openxmlformats.org/drawingml/2006/main" xmlns:r="http://schemas.openxmlformats.org/officeDocument/2006/relationships" xmlns:p="http://schemas.openxmlformats.org/presentationml/2006/main">
-  <p:cSld name="Slide 16">
-    <p:spTree>
-      <p:nvGrpSpPr>
-        <p:cNvPr id="1" name=""/>
-        <p:cNvGrpSpPr/>
-        <p:nvPr/>
-      </p:nvGrpSpPr>
-      <p:grpSpPr>
-        <a:xfrm>
-          <a:off x="0" y="0"/>
-          <a:ext cx="0" cy="0"/>
-          <a:chOff x="0" y="0"/>
-          <a:chExt cx="0" cy="0"/>
-        </a:xfrm>
-      </p:grpSpPr>
-      <p:sp>
-        <p:nvSpPr>
-          <p:cNvPr id="2" name="Text 1"/>
-          <p:cNvSpPr/>
-          <p:nvPr>
-            <p:ph idx="101" type="title" hasCustomPrompt="1"/>
-          </p:nvPr>
-        </p:nvSpPr>
-        <p:spPr>
-          <a:xfrm>
-            <a:off x="548640" y="365760"/>
-            <a:ext cx="8595360" cy="822960"/>
-          </a:xfrm>
-          <a:prstGeom prst="rect">
-            <a:avLst/>
-          </a:prstGeom>
-          <a:noFill/>
-          <a:ln/>
-        </p:spPr>
-        <p:txBody>
-          <a:bodyPr wrap="square" lIns="0" tIns="0" rIns="0" bIns="0" rtlCol="0" anchor="ctr"/>
-          <a:lstStyle/>
-          <a:p>
-            <a:pPr algn="l" indent="0" marL="0">
-              <a:buNone/>
-            </a:pPr>
-            <a:r>
-              <a:rPr lang="en-US" sz="3400" b="1" dirty="0">
-                <a:solidFill>
-                  <a:schemeClr val="tx1"/>
-                </a:solidFill>
-                <a:latin typeface="Cambria" pitchFamily="34" charset="0"/>
-                <a:ea typeface="Cambria" pitchFamily="34" charset="-122"/>
-                <a:cs typeface="Cambria" pitchFamily="34" charset="-120"/>
-              </a:rPr>
-              <a:t>Troubleshooting lab</a:t>
-            </a:r>
-            <a:endParaRPr lang="en-US" sz="3400" dirty="0"/>
-          </a:p>
-        </p:txBody>
-      </p:sp>
-      <p:sp>
-        <p:nvSpPr>
-          <p:cNvPr id="3" name="lab card 1"/>
-          <p:cNvSpPr/>
-          <p:nvPr/>
-        </p:nvSpPr>
-        <p:spPr>
-          <a:xfrm>
-            <a:off x="548640" y="1463040"/>
-            <a:ext cx="3566160" cy="4023360"/>
-          </a:xfrm>
-          <a:prstGeom prst="roundRect">
-            <a:avLst>
-              <a:gd name="adj" fmla="val 3077"/>
-            </a:avLst>
-          </a:prstGeom>
-          <a:solidFill>
-            <a:schemeClr val="bg2"/>
-          </a:solidFill>
-          <a:ln/>
-        </p:spPr>
-      </p:sp>
-      <p:sp>
-        <p:nvSpPr>
-          <p:cNvPr id="4" name="lab number 1"/>
-          <p:cNvSpPr/>
-          <p:nvPr/>
-        </p:nvSpPr>
-        <p:spPr>
-          <a:xfrm>
-            <a:off x="777240" y="1691640"/>
-            <a:ext cx="548640" cy="548640"/>
-          </a:xfrm>
-          <a:prstGeom prst="ellipse">
-            <a:avLst/>
-          </a:prstGeom>
-          <a:solidFill>
-            <a:schemeClr val="accent1"/>
-          </a:solidFill>
-          <a:ln/>
-        </p:spPr>
-      </p:sp>
-      <p:sp>
-        <p:nvSpPr>
-          <p:cNvPr id="5" name="lab number text 1"/>
-          <p:cNvSpPr txBox="1"/>
-          <p:nvPr/>
-        </p:nvSpPr>
-        <p:spPr>
-          <a:xfrm>
-            <a:off x="777240" y="1691640"/>
-            <a:ext cx="548640" cy="548640"/>
-          </a:xfrm>
-          <a:prstGeom prst="rect">
-            <a:avLst/>
-          </a:prstGeom>
-          <a:noFill/>
-          <a:ln/>
-        </p:spPr>
-        <p:txBody>
-          <a:bodyPr wrap="square" lIns="0" tIns="0" rIns="0" bIns="0" rtlCol="0" anchor="ctr"/>
-          <a:lstStyle/>
-          <a:p>
-            <a:pPr algn="ctr" indent="0" marL="0">
-              <a:buNone/>
-            </a:pPr>
-            <a:r>
-              <a:rPr lang="en-US" sz="2000" b="1" dirty="0">
-                <a:solidFill>
-                  <a:schemeClr val="bg1"/>
-                </a:solidFill>
-              </a:rPr>
-              <a:t>1</a:t>
-            </a:r>
-            <a:endParaRPr lang="en-US" sz="2000" dirty="0"/>
-          </a:p>
-        </p:txBody>
-      </p:sp>
-      <p:sp>
-        <p:nvSpPr>
-          <p:cNvPr id="6" name="lab title 1"/>
-          <p:cNvSpPr txBox="1"/>
-          <p:nvPr/>
-        </p:nvSpPr>
-        <p:spPr>
-          <a:xfrm>
-            <a:off x="1463040" y="1645920"/>
-            <a:ext cx="2468880" cy="640080"/>
-          </a:xfrm>
-          <a:prstGeom prst="rect">
-            <a:avLst/>
-          </a:prstGeom>
-          <a:noFill/>
-          <a:ln/>
-        </p:spPr>
-        <p:txBody>
-          <a:bodyPr wrap="square" lIns="0" tIns="0" rIns="0" bIns="0" rtlCol="0" anchor="ctr"/>
-          <a:lstStyle/>
-          <a:p>
-            <a:pPr indent="0" marL="0">
-              <a:buNone/>
-            </a:pPr>
-            <a:r>
-              <a:rPr lang="en-US" sz="2000" b="1" dirty="0">
-                <a:solidFill>
-                  <a:schemeClr val="tx1"/>
-                </a:solidFill>
-                <a:latin typeface="Cambria" pitchFamily="34" charset="0"/>
-                <a:ea typeface="Cambria" pitchFamily="34" charset="-122"/>
-                <a:cs typeface="Cambria" pitchFamily="34" charset="-120"/>
-              </a:rPr>
-              <a:t>Bad image tag</a:t>
-            </a:r>
-            <a:endParaRPr lang="en-US" sz="2000" dirty="0"/>
-          </a:p>
-        </p:txBody>
-      </p:sp>
-      <p:sp>
-        <p:nvSpPr>
-          <p:cNvPr id="7" name="lab body 1"/>
-          <p:cNvSpPr txBox="1"/>
-          <p:nvPr/>
-        </p:nvSpPr>
-        <p:spPr>
-          <a:xfrm>
-            <a:off x="777240" y="2514600"/>
-            <a:ext cx="3108960" cy="2834640"/>
-          </a:xfrm>
-          <a:prstGeom prst="rect">
-            <a:avLst/>
-          </a:prstGeom>
-          <a:noFill/>
-          <a:ln/>
-        </p:spPr>
-        <p:txBody>
-          <a:bodyPr wrap="square" lIns="0" tIns="0" rIns="0" bIns="0" rtlCol="0" anchor="t"/>
-          <a:lstStyle/>
-          <a:p>
-            <a:pPr indent="0" marL="0">
-              <a:buNone/>
-            </a:pPr>
-            <a:r>
-              <a:rPr lang="en-US" sz="1600" b="1" dirty="0">
-                <a:solidFill>
-                  <a:schemeClr val="accent1"/>
-                </a:solidFill>
-              </a:rPr>
-              <a:t>Symptom</a:t>
-            </a:r>
-            <a:endParaRPr lang="en-US" sz="1600" dirty="0"/>
-          </a:p>
-          <a:p>
-            <a:pPr indent="0" marL="0">
-              <a:spcAft>
-                <a:spcPts val="1200"/>
-              </a:spcAft>
-              <a:buNone/>
-            </a:pPr>
-            <a:r>
-              <a:rPr lang="en-US" sz="1600" dirty="0">
-                <a:solidFill>
-                  <a:schemeClr val="tx1"/>
-                </a:solidFill>
-              </a:rPr>
-              <a:t>ImagePullBackOff</a:t>
-            </a:r>
-            <a:endParaRPr lang="en-US" sz="1600" dirty="0"/>
-          </a:p>
-          <a:p>
-            <a:pPr indent="0" marL="0">
-              <a:buNone/>
-            </a:pPr>
-            <a:r>
-              <a:rPr lang="en-US" sz="1600" b="1" dirty="0">
-                <a:solidFill>
-                  <a:schemeClr val="accent1"/>
-                </a:solidFill>
-              </a:rPr>
-              <a:t>Diagnose</a:t>
-            </a:r>
-            <a:endParaRPr lang="en-US" sz="1600" dirty="0"/>
-          </a:p>
-          <a:p>
-            <a:pPr indent="0" marL="0">
-              <a:spcAft>
-                <a:spcPts val="1200"/>
-              </a:spcAft>
-              <a:buNone/>
-            </a:pPr>
-            <a:r>
-              <a:rPr lang="en-US" sz="1300" dirty="0">
-                <a:solidFill>
-                  <a:schemeClr val="tx1"/>
-                </a:solidFill>
-                <a:latin typeface="Courier New" pitchFamily="34" charset="0"/>
-                <a:ea typeface="Courier New" pitchFamily="34" charset="-122"/>
-                <a:cs typeface="Courier New" pitchFamily="34" charset="-120"/>
-              </a:rPr>
-              <a:t>kubectl describe pod</a:t>
-            </a:r>
-            <a:endParaRPr lang="en-US" sz="1600" dirty="0"/>
-          </a:p>
-          <a:p>
-            <a:pPr indent="0" marL="0">
-              <a:spcAft>
-                <a:spcPts val="1200"/>
-              </a:spcAft>
-              <a:buNone/>
-            </a:pPr>
-            <a:r>
-              <a:rPr lang="en-US" sz="1300" dirty="0">
-                <a:solidFill>
-                  <a:schemeClr val="tx1"/>
-                </a:solidFill>
-                <a:latin typeface="Courier New" pitchFamily="34" charset="0"/>
-                <a:ea typeface="Courier New" pitchFamily="34" charset="-122"/>
-                <a:cs typeface="Courier New" pitchFamily="34" charset="-120"/>
-              </a:rPr>
-              <a:t>kubectl get events</a:t>
-            </a:r>
-            <a:endParaRPr lang="en-US" sz="1600" dirty="0"/>
-          </a:p>
-          <a:p>
-            <a:pPr indent="0" marL="0">
-              <a:buNone/>
-            </a:pPr>
-            <a:r>
-              <a:rPr lang="en-US" sz="1600" b="1" dirty="0">
-                <a:solidFill>
-                  <a:schemeClr val="accent1"/>
-                </a:solidFill>
-              </a:rPr>
-              <a:t>Fix</a:t>
-            </a:r>
-            <a:endParaRPr lang="en-US" sz="1600" dirty="0"/>
-          </a:p>
-          <a:p>
-            <a:pPr indent="0" marL="0">
-              <a:buNone/>
-            </a:pPr>
-            <a:r>
-              <a:rPr lang="en-US" sz="1600" dirty="0">
-                <a:solidFill>
-                  <a:schemeClr val="tx1"/>
-                </a:solidFill>
-              </a:rPr>
-              <a:t>Correct the image tag</a:t>
-            </a:r>
-            <a:endParaRPr lang="en-US" sz="1600" dirty="0"/>
-          </a:p>
-        </p:txBody>
-      </p:sp>
-      <p:sp>
-        <p:nvSpPr>
-          <p:cNvPr id="8" name="lab card 2"/>
-          <p:cNvSpPr/>
-          <p:nvPr/>
-        </p:nvSpPr>
-        <p:spPr>
-          <a:xfrm>
-            <a:off x="4297680" y="1463040"/>
-            <a:ext cx="3566160" cy="4023360"/>
-          </a:xfrm>
-          <a:prstGeom prst="roundRect">
-            <a:avLst>
-              <a:gd name="adj" fmla="val 3077"/>
-            </a:avLst>
-          </a:prstGeom>
-          <a:solidFill>
-            <a:schemeClr val="bg2"/>
-          </a:solidFill>
-          <a:ln/>
-        </p:spPr>
-      </p:sp>
-      <p:sp>
-        <p:nvSpPr>
-          <p:cNvPr id="9" name="lab number 2"/>
-          <p:cNvSpPr/>
-          <p:nvPr/>
-        </p:nvSpPr>
-        <p:spPr>
-          <a:xfrm>
-            <a:off x="4526280" y="1691640"/>
-            <a:ext cx="548640" cy="548640"/>
-          </a:xfrm>
-          <a:prstGeom prst="ellipse">
-            <a:avLst/>
-          </a:prstGeom>
-          <a:solidFill>
-            <a:schemeClr val="accent1"/>
-          </a:solidFill>
-          <a:ln/>
-        </p:spPr>
-      </p:sp>
-      <p:sp>
-        <p:nvSpPr>
-          <p:cNvPr id="10" name="lab number text 2"/>
-          <p:cNvSpPr txBox="1"/>
-          <p:nvPr/>
-        </p:nvSpPr>
-        <p:spPr>
-          <a:xfrm>
-            <a:off x="4526280" y="1691640"/>
-            <a:ext cx="548640" cy="548640"/>
-          </a:xfrm>
-          <a:prstGeom prst="rect">
-            <a:avLst/>
-          </a:prstGeom>
-          <a:noFill/>
-          <a:ln/>
-        </p:spPr>
-        <p:txBody>
-          <a:bodyPr wrap="square" lIns="0" tIns="0" rIns="0" bIns="0" rtlCol="0" anchor="ctr"/>
-          <a:lstStyle/>
-          <a:p>
-            <a:pPr algn="ctr" indent="0" marL="0">
-              <a:buNone/>
-            </a:pPr>
-            <a:r>
-              <a:rPr lang="en-US" sz="2000" b="1" dirty="0">
-                <a:solidFill>
-                  <a:schemeClr val="bg1"/>
-                </a:solidFill>
-              </a:rPr>
-              <a:t>2</a:t>
-            </a:r>
-            <a:endParaRPr lang="en-US" sz="2000" dirty="0"/>
-          </a:p>
-        </p:txBody>
-      </p:sp>
-      <p:sp>
-        <p:nvSpPr>
-          <p:cNvPr id="11" name="lab title 2"/>
-          <p:cNvSpPr txBox="1"/>
-          <p:nvPr/>
-        </p:nvSpPr>
-        <p:spPr>
-          <a:xfrm>
-            <a:off x="5212080" y="1645920"/>
-            <a:ext cx="2468880" cy="640080"/>
-          </a:xfrm>
-          <a:prstGeom prst="rect">
-            <a:avLst/>
-          </a:prstGeom>
-          <a:noFill/>
-          <a:ln/>
-        </p:spPr>
-        <p:txBody>
-          <a:bodyPr wrap="square" lIns="0" tIns="0" rIns="0" bIns="0" rtlCol="0" anchor="ctr"/>
-          <a:lstStyle/>
-          <a:p>
-            <a:pPr indent="0" marL="0">
-              <a:buNone/>
-            </a:pPr>
-            <a:r>
-              <a:rPr lang="en-US" sz="2000" b="1" dirty="0">
-                <a:solidFill>
-                  <a:schemeClr val="tx1"/>
-                </a:solidFill>
-                <a:latin typeface="Cambria" pitchFamily="34" charset="0"/>
-                <a:ea typeface="Cambria" pitchFamily="34" charset="-122"/>
-                <a:cs typeface="Cambria" pitchFamily="34" charset="-120"/>
-              </a:rPr>
-              <a:t>Service has no endpoints</a:t>
-            </a:r>
-            <a:endParaRPr lang="en-US" sz="2000" dirty="0"/>
-          </a:p>
-        </p:txBody>
-      </p:sp>
-      <p:sp>
-        <p:nvSpPr>
-          <p:cNvPr id="12" name="lab body 2"/>
-          <p:cNvSpPr txBox="1"/>
-          <p:nvPr/>
-        </p:nvSpPr>
-        <p:spPr>
-          <a:xfrm>
-            <a:off x="4526280" y="2514600"/>
-            <a:ext cx="3108960" cy="2834640"/>
-          </a:xfrm>
-          <a:prstGeom prst="rect">
-            <a:avLst/>
-          </a:prstGeom>
-          <a:noFill/>
-          <a:ln/>
-        </p:spPr>
-        <p:txBody>
-          <a:bodyPr wrap="square" lIns="0" tIns="0" rIns="0" bIns="0" rtlCol="0" anchor="t"/>
-          <a:lstStyle/>
-          <a:p>
-            <a:pPr indent="0" marL="0">
-              <a:buNone/>
-            </a:pPr>
-            <a:r>
-              <a:rPr lang="en-US" sz="1600" b="1" dirty="0">
-                <a:solidFill>
-                  <a:schemeClr val="accent1"/>
-                </a:solidFill>
-              </a:rPr>
-              <a:t>Symptom</a:t>
-            </a:r>
-            <a:endParaRPr lang="en-US" sz="1600" dirty="0"/>
-          </a:p>
-          <a:p>
-            <a:pPr indent="0" marL="0">
-              <a:spcAft>
-                <a:spcPts val="1200"/>
-              </a:spcAft>
-              <a:buNone/>
-            </a:pPr>
-            <a:r>
-              <a:rPr lang="en-US" sz="1600" dirty="0">
-                <a:solidFill>
-                  <a:schemeClr val="tx1"/>
-                </a:solidFill>
-              </a:rPr>
-              <a:t>Label mismatch</a:t>
-            </a:r>
-            <a:endParaRPr lang="en-US" sz="1600" dirty="0"/>
-          </a:p>
-          <a:p>
-            <a:pPr indent="0" marL="0">
-              <a:buNone/>
-            </a:pPr>
-            <a:r>
-              <a:rPr lang="en-US" sz="1600" b="1" dirty="0">
-                <a:solidFill>
-                  <a:schemeClr val="accent1"/>
-                </a:solidFill>
-              </a:rPr>
-              <a:t>Diagnose</a:t>
-            </a:r>
-            <a:endParaRPr lang="en-US" sz="1600" dirty="0"/>
-          </a:p>
-          <a:p>
-            <a:pPr indent="0" marL="0">
-              <a:spcAft>
-                <a:spcPts val="1200"/>
-              </a:spcAft>
-              <a:buNone/>
-            </a:pPr>
-            <a:r>
-              <a:rPr lang="en-US" sz="1300" dirty="0">
-                <a:solidFill>
-                  <a:schemeClr val="tx1"/>
-                </a:solidFill>
-                <a:latin typeface="Courier New" pitchFamily="34" charset="0"/>
-                <a:ea typeface="Courier New" pitchFamily="34" charset="-122"/>
-                <a:cs typeface="Courier New" pitchFamily="34" charset="-120"/>
-              </a:rPr>
-              <a:t>kubectl get endpoints</a:t>
-            </a:r>
-            <a:endParaRPr lang="en-US" sz="1600" dirty="0"/>
-          </a:p>
-          <a:p>
-            <a:pPr indent="0" marL="0">
-              <a:spcAft>
-                <a:spcPts val="1200"/>
-              </a:spcAft>
-              <a:buNone/>
-            </a:pPr>
-            <a:r>
-              <a:rPr lang="en-US" sz="1300" dirty="0">
-                <a:solidFill>
-                  <a:schemeClr val="tx1"/>
-                </a:solidFill>
-                <a:latin typeface="Courier New" pitchFamily="34" charset="0"/>
-                <a:ea typeface="Courier New" pitchFamily="34" charset="-122"/>
-                <a:cs typeface="Courier New" pitchFamily="34" charset="-120"/>
-              </a:rPr>
-              <a:t>kubectl get pods --show-labels</a:t>
-            </a:r>
-            <a:endParaRPr lang="en-US" sz="1600" dirty="0"/>
-          </a:p>
-          <a:p>
-            <a:pPr indent="0" marL="0">
-              <a:buNone/>
-            </a:pPr>
-            <a:r>
-              <a:rPr lang="en-US" sz="1600" b="1" dirty="0">
-                <a:solidFill>
-                  <a:schemeClr val="accent1"/>
-                </a:solidFill>
-              </a:rPr>
-              <a:t>Fix</a:t>
-            </a:r>
-            <a:endParaRPr lang="en-US" sz="1600" dirty="0"/>
-          </a:p>
-          <a:p>
-            <a:pPr indent="0" marL="0">
-              <a:buNone/>
-            </a:pPr>
-            <a:r>
-              <a:rPr lang="en-US" sz="1600" dirty="0">
-                <a:solidFill>
-                  <a:schemeClr val="tx1"/>
-                </a:solidFill>
-              </a:rPr>
-              <a:t>Patch the Service selector</a:t>
-            </a:r>
-            <a:endParaRPr lang="en-US" sz="1600" dirty="0"/>
-          </a:p>
-        </p:txBody>
-      </p:sp>
-      <p:sp>
-        <p:nvSpPr>
-          <p:cNvPr id="13" name="lab card 3"/>
-          <p:cNvSpPr/>
-          <p:nvPr/>
-        </p:nvSpPr>
-        <p:spPr>
-          <a:xfrm>
-            <a:off x="8046720" y="1463040"/>
-            <a:ext cx="3566160" cy="4023360"/>
-          </a:xfrm>
-          <a:prstGeom prst="roundRect">
-            <a:avLst>
-              <a:gd name="adj" fmla="val 3077"/>
-            </a:avLst>
-          </a:prstGeom>
-          <a:solidFill>
-            <a:schemeClr val="bg2"/>
-          </a:solidFill>
-          <a:ln/>
-        </p:spPr>
-      </p:sp>
-      <p:sp>
-        <p:nvSpPr>
-          <p:cNvPr id="14" name="lab number 3"/>
-          <p:cNvSpPr/>
-          <p:nvPr/>
-        </p:nvSpPr>
-        <p:spPr>
-          <a:xfrm>
-            <a:off x="8275320" y="1691640"/>
-            <a:ext cx="548640" cy="548640"/>
-          </a:xfrm>
-          <a:prstGeom prst="ellipse">
-            <a:avLst/>
-          </a:prstGeom>
-          <a:solidFill>
-            <a:schemeClr val="accent1"/>
-          </a:solidFill>
-          <a:ln/>
-        </p:spPr>
-      </p:sp>
-      <p:sp>
-        <p:nvSpPr>
-          <p:cNvPr id="15" name="lab number text 3"/>
-          <p:cNvSpPr txBox="1"/>
-          <p:nvPr/>
-        </p:nvSpPr>
-        <p:spPr>
-          <a:xfrm>
-            <a:off x="8275320" y="1691640"/>
-            <a:ext cx="548640" cy="548640"/>
-          </a:xfrm>
-          <a:prstGeom prst="rect">
-            <a:avLst/>
-          </a:prstGeom>
-          <a:noFill/>
-          <a:ln/>
-        </p:spPr>
-        <p:txBody>
-          <a:bodyPr wrap="square" lIns="0" tIns="0" rIns="0" bIns="0" rtlCol="0" anchor="ctr"/>
-          <a:lstStyle/>
-          <a:p>
-            <a:pPr algn="ctr" indent="0" marL="0">
-              <a:buNone/>
-            </a:pPr>
-            <a:r>
-              <a:rPr lang="en-US" sz="2000" b="1" dirty="0">
-                <a:solidFill>
-                  <a:schemeClr val="bg1"/>
-                </a:solidFill>
-              </a:rPr>
-              <a:t>3</a:t>
-            </a:r>
-            <a:endParaRPr lang="en-US" sz="2000" dirty="0"/>
-          </a:p>
-        </p:txBody>
-      </p:sp>
-      <p:sp>
-        <p:nvSpPr>
-          <p:cNvPr id="16" name="lab title 3"/>
-          <p:cNvSpPr txBox="1"/>
-          <p:nvPr/>
-        </p:nvSpPr>
-        <p:spPr>
-          <a:xfrm>
-            <a:off x="8961120" y="1645920"/>
-            <a:ext cx="2468880" cy="640080"/>
-          </a:xfrm>
-          <a:prstGeom prst="rect">
-            <a:avLst/>
-          </a:prstGeom>
-          <a:noFill/>
-          <a:ln/>
-        </p:spPr>
-        <p:txBody>
-          <a:bodyPr wrap="square" lIns="0" tIns="0" rIns="0" bIns="0" rtlCol="0" anchor="ctr"/>
-          <a:lstStyle/>
-          <a:p>
-            <a:pPr indent="0" marL="0">
-              <a:buNone/>
-            </a:pPr>
-            <a:r>
-              <a:rPr lang="en-US" sz="2000" b="1" dirty="0">
-                <a:solidFill>
-                  <a:schemeClr val="tx1"/>
-                </a:solidFill>
-                <a:latin typeface="Cambria" pitchFamily="34" charset="0"/>
-                <a:ea typeface="Cambria" pitchFamily="34" charset="-122"/>
-                <a:cs typeface="Cambria" pitchFamily="34" charset="-120"/>
-              </a:rPr>
-              <a:t>Pod never Ready</a:t>
-            </a:r>
-            <a:endParaRPr lang="en-US" sz="2000" dirty="0"/>
-          </a:p>
-        </p:txBody>
-      </p:sp>
-      <p:sp>
-        <p:nvSpPr>
-          <p:cNvPr id="17" name="lab body 3"/>
-          <p:cNvSpPr txBox="1"/>
-          <p:nvPr/>
-        </p:nvSpPr>
-        <p:spPr>
-          <a:xfrm>
-            <a:off x="8275320" y="2514600"/>
-            <a:ext cx="3108960" cy="2834640"/>
-          </a:xfrm>
-          <a:prstGeom prst="rect">
-            <a:avLst/>
-          </a:prstGeom>
-          <a:noFill/>
-          <a:ln/>
-        </p:spPr>
-        <p:txBody>
-          <a:bodyPr wrap="square" lIns="0" tIns="0" rIns="0" bIns="0" rtlCol="0" anchor="t"/>
-          <a:lstStyle/>
-          <a:p>
-            <a:pPr indent="0" marL="0">
-              <a:buNone/>
-            </a:pPr>
-            <a:r>
-              <a:rPr lang="en-US" sz="1600" b="1" dirty="0">
-                <a:solidFill>
-                  <a:schemeClr val="accent1"/>
-                </a:solidFill>
-              </a:rPr>
-              <a:t>Symptom</a:t>
-            </a:r>
-            <a:endParaRPr lang="en-US" sz="1600" dirty="0"/>
-          </a:p>
-          <a:p>
-            <a:pPr indent="0" marL="0">
-              <a:spcAft>
-                <a:spcPts val="1200"/>
-              </a:spcAft>
-              <a:buNone/>
-            </a:pPr>
-            <a:r>
-              <a:rPr lang="en-US" sz="1600" dirty="0">
-                <a:solidFill>
-                  <a:schemeClr val="tx1"/>
-                </a:solidFill>
-              </a:rPr>
-              <a:t>Wrong readiness path</a:t>
-            </a:r>
-            <a:endParaRPr lang="en-US" sz="1600" dirty="0"/>
-          </a:p>
-          <a:p>
-            <a:pPr indent="0" marL="0">
-              <a:buNone/>
-            </a:pPr>
-            <a:r>
-              <a:rPr lang="en-US" sz="1600" b="1" dirty="0">
-                <a:solidFill>
-                  <a:schemeClr val="accent1"/>
-                </a:solidFill>
-              </a:rPr>
-              <a:t>Diagnose</a:t>
-            </a:r>
-            <a:endParaRPr lang="en-US" sz="1600" dirty="0"/>
-          </a:p>
-          <a:p>
-            <a:pPr indent="0" marL="0">
-              <a:spcAft>
-                <a:spcPts val="1200"/>
-              </a:spcAft>
-              <a:buNone/>
-            </a:pPr>
-            <a:r>
-              <a:rPr lang="en-US" sz="1300" dirty="0">
-                <a:solidFill>
-                  <a:schemeClr val="tx1"/>
-                </a:solidFill>
-                <a:latin typeface="Courier New" pitchFamily="34" charset="0"/>
-                <a:ea typeface="Courier New" pitchFamily="34" charset="-122"/>
-                <a:cs typeface="Courier New" pitchFamily="34" charset="-120"/>
-              </a:rPr>
-              <a:t>kubectl describe pod</a:t>
-            </a:r>
-            <a:endParaRPr lang="en-US" sz="1600" dirty="0"/>
-          </a:p>
-          <a:p>
-            <a:pPr indent="0" marL="0">
-              <a:spcAft>
-                <a:spcPts val="1200"/>
-              </a:spcAft>
-              <a:buNone/>
-            </a:pPr>
-            <a:r>
-              <a:rPr lang="en-US" sz="1300" dirty="0">
-                <a:solidFill>
-                  <a:schemeClr val="tx1"/>
-                </a:solidFill>
-                <a:latin typeface="Courier New" pitchFamily="34" charset="0"/>
-                <a:ea typeface="Courier New" pitchFamily="34" charset="-122"/>
-                <a:cs typeface="Courier New" pitchFamily="34" charset="-120"/>
-              </a:rPr>
-              <a:t>look at probe events</a:t>
-            </a:r>
-            <a:endParaRPr lang="en-US" sz="1600" dirty="0"/>
-          </a:p>
-          <a:p>
-            <a:pPr indent="0" marL="0">
-              <a:buNone/>
-            </a:pPr>
-            <a:r>
-              <a:rPr lang="en-US" sz="1600" b="1" dirty="0">
-                <a:solidFill>
-                  <a:schemeClr val="accent1"/>
-                </a:solidFill>
-              </a:rPr>
-              <a:t>Fix</a:t>
-            </a:r>
-            <a:endParaRPr lang="en-US" sz="1600" dirty="0"/>
-          </a:p>
-          <a:p>
-            <a:pPr indent="0" marL="0">
-              <a:buNone/>
-            </a:pPr>
-            <a:r>
-              <a:rPr lang="en-US" sz="1600" dirty="0">
-                <a:solidFill>
-                  <a:schemeClr val="tx1"/>
-                </a:solidFill>
-              </a:rPr>
-              <a:t>Fix the probe path</a:t>
-            </a:r>
-            <a:endParaRPr lang="en-US" sz="1600" dirty="0"/>
-          </a:p>
-        </p:txBody>
-      </p:sp>
-      <p:sp>
-        <p:nvSpPr>
-          <p:cNvPr id="25" name="Slide Number Placeholder 0"/>
-          <p:cNvSpPr>
-            <a:spLocks noGrp="1"/>
-          </p:cNvSpPr>
-          <p:nvPr>
-            <p:ph type="sldNum" sz="quarter" idx="4294967295"/>
-          </p:nvPr>
-        </p:nvSpPr>
-        <p:spPr>
-          <a:xfrm>
-            <a:off x="11155680" y="6400800"/>
-            <a:ext cx="548640" cy="274320"/>
-          </a:xfrm>
-          <a:prstGeom prst="rect">
-            <a:avLst/>
-          </a:prstGeom>
-          <a:extLst>
-            <a:ext uri="{C572A759-6A51-4108-AA02-DFA0A04FC94B}">
-              <ma14:wrappingTextBoxFlag xmlns:ma14="http://schemas.microsoft.com/office/mac/drawingml/2011/main" val="0"/>
-            </a:ext>
-          </a:extLst>
-        </p:spPr>
-        <p:txBody>
-          <a:bodyPr/>
-          <a:lstStyle>
-            <a:lvl1pPr>
-              <a:defRPr sz="1100">
-                <a:solidFill>
-                  <a:srgbClr val="64748B"/>
-                </a:solidFill>
-                <a:latin typeface="Calibri"/>
-                <a:ea typeface="Calibri"/>
-                <a:cs typeface="Calibri"/>
-              </a:defRPr>
-            </a:lvl1pPr>
-          </a:lstStyle>
-          <a:p>
-            <a:pPr algn="r"/>
-            <a:fld id="{F7021451-1387-4CA6-816F-3879F97B5CBC}" type="slidenum">
-              <a:rPr b="0" lang="en-US"/>
               <a:t>16</a:t>
             </a:fld>
             <a:endParaRPr lang="en-US"/>
@@ -8074,7 +7979,7 @@
                 <a:ea typeface="Cambria" pitchFamily="34" charset="-122"/>
                 <a:cs typeface="Cambria" pitchFamily="34" charset="-120"/>
               </a:rPr>
-              <a:t>Limits and next steps</a:t>
+              <a:t>Troubleshooting lab</a:t>
             </a:r>
             <a:endParaRPr lang="en-US" sz="3400" dirty="0"/>
           </a:p>
@@ -8082,14 +7987,56 @@
       </p:sp>
       <p:sp>
         <p:nvSpPr>
-          <p:cNvPr id="3" name="limits heading"/>
+          <p:cNvPr id="3" name="lab card 1"/>
+          <p:cNvSpPr/>
+          <p:nvPr/>
+        </p:nvSpPr>
+        <p:spPr>
+          <a:xfrm>
+            <a:off x="548640" y="1463040"/>
+            <a:ext cx="3566160" cy="4023360"/>
+          </a:xfrm>
+          <a:prstGeom prst="roundRect">
+            <a:avLst>
+              <a:gd name="adj" fmla="val 3077"/>
+            </a:avLst>
+          </a:prstGeom>
+          <a:solidFill>
+            <a:schemeClr val="bg2"/>
+          </a:solidFill>
+          <a:ln/>
+        </p:spPr>
+      </p:sp>
+      <p:sp>
+        <p:nvSpPr>
+          <p:cNvPr id="4" name="lab number 1"/>
+          <p:cNvSpPr/>
+          <p:nvPr/>
+        </p:nvSpPr>
+        <p:spPr>
+          <a:xfrm>
+            <a:off x="777240" y="1691640"/>
+            <a:ext cx="548640" cy="548640"/>
+          </a:xfrm>
+          <a:prstGeom prst="ellipse">
+            <a:avLst/>
+          </a:prstGeom>
+          <a:solidFill>
+            <a:schemeClr val="accent1"/>
+          </a:solidFill>
+          <a:ln/>
+        </p:spPr>
+      </p:sp>
+      <p:sp>
+        <p:nvSpPr>
+          <p:cNvPr id="5" name="lab number text 1"/>
           <p:cNvSpPr txBox="1"/>
           <p:nvPr/>
         </p:nvSpPr>
         <p:spPr>
           <a:xfrm>
-            <a:off x="548640" y="1417320"/>
-            <a:ext cx="5303520" cy="457200"/>
+            <a:off x="777240" y="1691640"/>
+            <a:ext cx="548640" cy="548640"/>
           </a:xfrm>
           <a:prstGeom prst="rect">
             <a:avLst/>
@@ -8101,34 +8048,70 @@
           <a:bodyPr wrap="square" lIns="0" tIns="0" rIns="0" bIns="0" rtlCol="0" anchor="ctr"/>
           <a:lstStyle/>
           <a:p>
+            <a:pPr algn="ctr" indent="0" marL="0">
+              <a:buNone/>
+            </a:pPr>
+            <a:r>
+              <a:rPr lang="en-US" sz="2000" b="1" dirty="0">
+                <a:solidFill>
+                  <a:schemeClr val="bg1"/>
+                </a:solidFill>
+              </a:rPr>
+              <a:t>1</a:t>
+            </a:r>
+            <a:endParaRPr lang="en-US" sz="2000" dirty="0"/>
+          </a:p>
+        </p:txBody>
+      </p:sp>
+      <p:sp>
+        <p:nvSpPr>
+          <p:cNvPr id="6" name="lab title 1"/>
+          <p:cNvSpPr txBox="1"/>
+          <p:nvPr/>
+        </p:nvSpPr>
+        <p:spPr>
+          <a:xfrm>
+            <a:off x="1463040" y="1645920"/>
+            <a:ext cx="2468880" cy="640080"/>
+          </a:xfrm>
+          <a:prstGeom prst="rect">
+            <a:avLst/>
+          </a:prstGeom>
+          <a:noFill/>
+          <a:ln/>
+        </p:spPr>
+        <p:txBody>
+          <a:bodyPr wrap="square" lIns="0" tIns="0" rIns="0" bIns="0" rtlCol="0" anchor="ctr"/>
+          <a:lstStyle/>
+          <a:p>
             <a:pPr indent="0" marL="0">
               <a:buNone/>
             </a:pPr>
             <a:r>
-              <a:rPr lang="en-US" sz="2400" b="1" dirty="0">
-                <a:solidFill>
-                  <a:schemeClr val="accent4"/>
+              <a:rPr lang="en-US" sz="2000" b="1" dirty="0">
+                <a:solidFill>
+                  <a:schemeClr val="tx1"/>
                 </a:solidFill>
                 <a:latin typeface="Cambria" pitchFamily="34" charset="0"/>
                 <a:ea typeface="Cambria" pitchFamily="34" charset="-122"/>
                 <a:cs typeface="Cambria" pitchFamily="34" charset="-120"/>
               </a:rPr>
-              <a:t>Known limits</a:t>
-            </a:r>
-            <a:endParaRPr lang="en-US" sz="2400" dirty="0"/>
-          </a:p>
-        </p:txBody>
-      </p:sp>
-      <p:sp>
-        <p:nvSpPr>
-          <p:cNvPr id="4" name="bullets"/>
+              <a:t>Bad image tag</a:t>
+            </a:r>
+            <a:endParaRPr lang="en-US" sz="2000" dirty="0"/>
+          </a:p>
+        </p:txBody>
+      </p:sp>
+      <p:sp>
+        <p:nvSpPr>
+          <p:cNvPr id="7" name="lab body 1"/>
           <p:cNvSpPr txBox="1"/>
           <p:nvPr/>
         </p:nvSpPr>
         <p:spPr>
           <a:xfrm>
-            <a:off x="548640" y="1965960"/>
-            <a:ext cx="5303520" cy="4023360"/>
+            <a:off x="777240" y="2514600"/>
+            <a:ext cx="3108960" cy="2834640"/>
           </a:xfrm>
           <a:prstGeom prst="rect">
             <a:avLst/>
@@ -8140,12 +8123,25 @@
           <a:bodyPr wrap="square" lIns="0" tIns="0" rIns="0" bIns="0" rtlCol="0" anchor="t"/>
           <a:lstStyle/>
           <a:p>
-            <a:pPr marL="228600" indent="-228600">
+            <a:pPr indent="0" marL="0">
+              <a:buNone/>
+            </a:pPr>
+            <a:r>
+              <a:rPr lang="en-US" sz="1600" b="1" dirty="0">
+                <a:solidFill>
+                  <a:schemeClr val="accent1"/>
+                </a:solidFill>
+              </a:rPr>
+              <a:t>Symptom</a:t>
+            </a:r>
+            <a:endParaRPr lang="en-US" sz="1600" dirty="0"/>
+          </a:p>
+          <a:p>
+            <a:pPr indent="0" marL="0">
               <a:spcAft>
-                <a:spcPts val="1000"/>
+                <a:spcPts val="1200"/>
               </a:spcAft>
-              <a:buSzPct val="100000"/>
-              <a:buChar char="•"/>
+              <a:buNone/>
             </a:pPr>
             <a:r>
               <a:rPr lang="en-US" sz="1600" dirty="0">
@@ -8153,17 +8149,81 @@
                   <a:schemeClr val="tx1"/>
                 </a:solidFill>
               </a:rPr>
-              <a:t>The AWS account cannot create load balancers, so the Ingress is reached by port-forward.</a:t>
+              <a:t>ImagePullBackOff</a:t>
             </a:r>
             <a:endParaRPr lang="en-US" sz="1600" dirty="0"/>
           </a:p>
           <a:p>
-            <a:pPr marL="228600" indent="-228600">
+            <a:pPr indent="0" marL="0">
+              <a:buNone/>
+            </a:pPr>
+            <a:r>
+              <a:rPr lang="en-US" sz="1600" b="1" dirty="0">
+                <a:solidFill>
+                  <a:schemeClr val="accent1"/>
+                </a:solidFill>
+              </a:rPr>
+              <a:t>Diagnose</a:t>
+            </a:r>
+            <a:endParaRPr lang="en-US" sz="1600" dirty="0"/>
+          </a:p>
+          <a:p>
+            <a:pPr indent="0" marL="0">
               <a:spcAft>
-                <a:spcPts val="1000"/>
+                <a:spcPts val="1200"/>
               </a:spcAft>
-              <a:buSzPct val="100000"/>
-              <a:buChar char="•"/>
+              <a:buNone/>
+            </a:pPr>
+            <a:r>
+              <a:rPr lang="en-US" sz="1300" dirty="0">
+                <a:solidFill>
+                  <a:schemeClr val="tx1"/>
+                </a:solidFill>
+                <a:latin typeface="Courier New" pitchFamily="34" charset="0"/>
+                <a:ea typeface="Courier New" pitchFamily="34" charset="-122"/>
+                <a:cs typeface="Courier New" pitchFamily="34" charset="-120"/>
+              </a:rPr>
+              <a:t>kubectl describe pod</a:t>
+            </a:r>
+            <a:endParaRPr lang="en-US" sz="1600" dirty="0"/>
+          </a:p>
+          <a:p>
+            <a:pPr indent="0" marL="0">
+              <a:spcAft>
+                <a:spcPts val="1200"/>
+              </a:spcAft>
+              <a:buNone/>
+            </a:pPr>
+            <a:r>
+              <a:rPr lang="en-US" sz="1300" dirty="0">
+                <a:solidFill>
+                  <a:schemeClr val="tx1"/>
+                </a:solidFill>
+                <a:latin typeface="Courier New" pitchFamily="34" charset="0"/>
+                <a:ea typeface="Courier New" pitchFamily="34" charset="-122"/>
+                <a:cs typeface="Courier New" pitchFamily="34" charset="-120"/>
+              </a:rPr>
+              <a:t>kubectl get events</a:t>
+            </a:r>
+            <a:endParaRPr lang="en-US" sz="1600" dirty="0"/>
+          </a:p>
+          <a:p>
+            <a:pPr indent="0" marL="0">
+              <a:buNone/>
+            </a:pPr>
+            <a:r>
+              <a:rPr lang="en-US" sz="1600" b="1" dirty="0">
+                <a:solidFill>
+                  <a:schemeClr val="accent1"/>
+                </a:solidFill>
+              </a:rPr>
+              <a:t>Fix</a:t>
+            </a:r>
+            <a:endParaRPr lang="en-US" sz="1600" dirty="0"/>
+          </a:p>
+          <a:p>
+            <a:pPr indent="0" marL="0">
+              <a:buNone/>
             </a:pPr>
             <a:r>
               <a:rPr lang="en-US" sz="1600" dirty="0">
@@ -8171,79 +8231,139 @@
                   <a:schemeClr val="tx1"/>
                 </a:solidFill>
               </a:rPr>
-              <a:t>The pipeline's deploy job needs a kubeconfig secret that I did not set; I deployed with Helm from my laptop using the pipeline's images.</a:t>
+              <a:t>Correct the image tag</a:t>
             </a:r>
             <a:endParaRPr lang="en-US" sz="1600" dirty="0"/>
           </a:p>
-          <a:p>
-            <a:pPr marL="228600" indent="-228600">
-              <a:spcAft>
-                <a:spcPts val="1000"/>
-              </a:spcAft>
-              <a:buSzPct val="100000"/>
-              <a:buChar char="•"/>
-            </a:pPr>
-            <a:r>
-              <a:rPr lang="en-US" sz="1600" dirty="0">
+        </p:txBody>
+      </p:sp>
+      <p:sp>
+        <p:nvSpPr>
+          <p:cNvPr id="8" name="lab card 2"/>
+          <p:cNvSpPr/>
+          <p:nvPr/>
+        </p:nvSpPr>
+        <p:spPr>
+          <a:xfrm>
+            <a:off x="4297680" y="1463040"/>
+            <a:ext cx="3566160" cy="4023360"/>
+          </a:xfrm>
+          <a:prstGeom prst="roundRect">
+            <a:avLst>
+              <a:gd name="adj" fmla="val 3077"/>
+            </a:avLst>
+          </a:prstGeom>
+          <a:solidFill>
+            <a:schemeClr val="bg2"/>
+          </a:solidFill>
+          <a:ln/>
+        </p:spPr>
+      </p:sp>
+      <p:sp>
+        <p:nvSpPr>
+          <p:cNvPr id="9" name="lab number 2"/>
+          <p:cNvSpPr/>
+          <p:nvPr/>
+        </p:nvSpPr>
+        <p:spPr>
+          <a:xfrm>
+            <a:off x="4526280" y="1691640"/>
+            <a:ext cx="548640" cy="548640"/>
+          </a:xfrm>
+          <a:prstGeom prst="ellipse">
+            <a:avLst/>
+          </a:prstGeom>
+          <a:solidFill>
+            <a:schemeClr val="accent1"/>
+          </a:solidFill>
+          <a:ln/>
+        </p:spPr>
+      </p:sp>
+      <p:sp>
+        <p:nvSpPr>
+          <p:cNvPr id="10" name="lab number text 2"/>
+          <p:cNvSpPr txBox="1"/>
+          <p:nvPr/>
+        </p:nvSpPr>
+        <p:spPr>
+          <a:xfrm>
+            <a:off x="4526280" y="1691640"/>
+            <a:ext cx="548640" cy="548640"/>
+          </a:xfrm>
+          <a:prstGeom prst="rect">
+            <a:avLst/>
+          </a:prstGeom>
+          <a:noFill/>
+          <a:ln/>
+        </p:spPr>
+        <p:txBody>
+          <a:bodyPr wrap="square" lIns="0" tIns="0" rIns="0" bIns="0" rtlCol="0" anchor="ctr"/>
+          <a:lstStyle/>
+          <a:p>
+            <a:pPr algn="ctr" indent="0" marL="0">
+              <a:buNone/>
+            </a:pPr>
+            <a:r>
+              <a:rPr lang="en-US" sz="2000" b="1" dirty="0">
+                <a:solidFill>
+                  <a:schemeClr val="bg1"/>
+                </a:solidFill>
+              </a:rPr>
+              <a:t>2</a:t>
+            </a:r>
+            <a:endParaRPr lang="en-US" sz="2000" dirty="0"/>
+          </a:p>
+        </p:txBody>
+      </p:sp>
+      <p:sp>
+        <p:nvSpPr>
+          <p:cNvPr id="11" name="lab title 2"/>
+          <p:cNvSpPr txBox="1"/>
+          <p:nvPr/>
+        </p:nvSpPr>
+        <p:spPr>
+          <a:xfrm>
+            <a:off x="5212080" y="1645920"/>
+            <a:ext cx="2468880" cy="640080"/>
+          </a:xfrm>
+          <a:prstGeom prst="rect">
+            <a:avLst/>
+          </a:prstGeom>
+          <a:noFill/>
+          <a:ln/>
+        </p:spPr>
+        <p:txBody>
+          <a:bodyPr wrap="square" lIns="0" tIns="0" rIns="0" bIns="0" rtlCol="0" anchor="ctr"/>
+          <a:lstStyle/>
+          <a:p>
+            <a:pPr indent="0" marL="0">
+              <a:buNone/>
+            </a:pPr>
+            <a:r>
+              <a:rPr lang="en-US" sz="2000" b="1" dirty="0">
                 <a:solidFill>
                   <a:schemeClr val="tx1"/>
-                </a:solidFill>
-              </a:rPr>
-              <a:t>PostgreSQL runs inside the cluster for a self-contained capstone.</a:t>
-            </a:r>
-            <a:endParaRPr lang="en-US" sz="1600" dirty="0"/>
-          </a:p>
-        </p:txBody>
-      </p:sp>
-      <p:sp>
-        <p:nvSpPr>
-          <p:cNvPr id="5" name="next heading"/>
-          <p:cNvSpPr txBox="1"/>
-          <p:nvPr/>
-        </p:nvSpPr>
-        <p:spPr>
-          <a:xfrm>
-            <a:off x="6400800" y="1417320"/>
-            <a:ext cx="5212080" cy="457200"/>
-          </a:xfrm>
-          <a:prstGeom prst="rect">
-            <a:avLst/>
-          </a:prstGeom>
-          <a:noFill/>
-          <a:ln/>
-        </p:spPr>
-        <p:txBody>
-          <a:bodyPr wrap="square" lIns="0" tIns="0" rIns="0" bIns="0" rtlCol="0" anchor="ctr"/>
-          <a:lstStyle/>
-          <a:p>
-            <a:pPr indent="0" marL="0">
-              <a:buNone/>
-            </a:pPr>
-            <a:r>
-              <a:rPr lang="en-US" sz="2400" b="1" dirty="0">
-                <a:solidFill>
-                  <a:schemeClr val="accent1"/>
                 </a:solidFill>
                 <a:latin typeface="Cambria" pitchFamily="34" charset="0"/>
                 <a:ea typeface="Cambria" pitchFamily="34" charset="-122"/>
                 <a:cs typeface="Cambria" pitchFamily="34" charset="-120"/>
               </a:rPr>
-              <a:t>What I would do next</a:t>
-            </a:r>
-            <a:endParaRPr lang="en-US" sz="2400" dirty="0"/>
-          </a:p>
-        </p:txBody>
-      </p:sp>
-      <p:sp>
-        <p:nvSpPr>
-          <p:cNvPr id="6" name="bullets"/>
+              <a:t>Service has no endpoints</a:t>
+            </a:r>
+            <a:endParaRPr lang="en-US" sz="2000" dirty="0"/>
+          </a:p>
+        </p:txBody>
+      </p:sp>
+      <p:sp>
+        <p:nvSpPr>
+          <p:cNvPr id="12" name="lab body 2"/>
           <p:cNvSpPr txBox="1"/>
           <p:nvPr/>
         </p:nvSpPr>
         <p:spPr>
           <a:xfrm>
-            <a:off x="6400800" y="1965960"/>
-            <a:ext cx="5212080" cy="4023360"/>
+            <a:off x="4526280" y="2514600"/>
+            <a:ext cx="3108960" cy="2834640"/>
           </a:xfrm>
           <a:prstGeom prst="rect">
             <a:avLst/>
@@ -8255,12 +8375,25 @@
           <a:bodyPr wrap="square" lIns="0" tIns="0" rIns="0" bIns="0" rtlCol="0" anchor="t"/>
           <a:lstStyle/>
           <a:p>
-            <a:pPr marL="228600" indent="-228600">
+            <a:pPr indent="0" marL="0">
+              <a:buNone/>
+            </a:pPr>
+            <a:r>
+              <a:rPr lang="en-US" sz="1600" b="1" dirty="0">
+                <a:solidFill>
+                  <a:schemeClr val="accent1"/>
+                </a:solidFill>
+              </a:rPr>
+              <a:t>Symptom</a:t>
+            </a:r>
+            <a:endParaRPr lang="en-US" sz="1600" dirty="0"/>
+          </a:p>
+          <a:p>
+            <a:pPr indent="0" marL="0">
               <a:spcAft>
-                <a:spcPts val="1000"/>
+                <a:spcPts val="1200"/>
               </a:spcAft>
-              <a:buSzPct val="100000"/>
-              <a:buChar char="•"/>
+              <a:buNone/>
             </a:pPr>
             <a:r>
               <a:rPr lang="en-US" sz="1600" dirty="0">
@@ -8268,17 +8401,81 @@
                   <a:schemeClr val="tx1"/>
                 </a:solidFill>
               </a:rPr>
-              <a:t>Amazon RDS for backups and Multi-AZ failover.</a:t>
+              <a:t>Label mismatch</a:t>
             </a:r>
             <a:endParaRPr lang="en-US" sz="1600" dirty="0"/>
           </a:p>
           <a:p>
-            <a:pPr marL="228600" indent="-228600">
+            <a:pPr indent="0" marL="0">
+              <a:buNone/>
+            </a:pPr>
+            <a:r>
+              <a:rPr lang="en-US" sz="1600" b="1" dirty="0">
+                <a:solidFill>
+                  <a:schemeClr val="accent1"/>
+                </a:solidFill>
+              </a:rPr>
+              <a:t>Diagnose</a:t>
+            </a:r>
+            <a:endParaRPr lang="en-US" sz="1600" dirty="0"/>
+          </a:p>
+          <a:p>
+            <a:pPr indent="0" marL="0">
               <a:spcAft>
-                <a:spcPts val="1000"/>
+                <a:spcPts val="1200"/>
               </a:spcAft>
-              <a:buSzPct val="100000"/>
-              <a:buChar char="•"/>
+              <a:buNone/>
+            </a:pPr>
+            <a:r>
+              <a:rPr lang="en-US" sz="1300" dirty="0">
+                <a:solidFill>
+                  <a:schemeClr val="tx1"/>
+                </a:solidFill>
+                <a:latin typeface="Courier New" pitchFamily="34" charset="0"/>
+                <a:ea typeface="Courier New" pitchFamily="34" charset="-122"/>
+                <a:cs typeface="Courier New" pitchFamily="34" charset="-120"/>
+              </a:rPr>
+              <a:t>kubectl get endpoints</a:t>
+            </a:r>
+            <a:endParaRPr lang="en-US" sz="1600" dirty="0"/>
+          </a:p>
+          <a:p>
+            <a:pPr indent="0" marL="0">
+              <a:spcAft>
+                <a:spcPts val="1200"/>
+              </a:spcAft>
+              <a:buNone/>
+            </a:pPr>
+            <a:r>
+              <a:rPr lang="en-US" sz="1300" dirty="0">
+                <a:solidFill>
+                  <a:schemeClr val="tx1"/>
+                </a:solidFill>
+                <a:latin typeface="Courier New" pitchFamily="34" charset="0"/>
+                <a:ea typeface="Courier New" pitchFamily="34" charset="-122"/>
+                <a:cs typeface="Courier New" pitchFamily="34" charset="-120"/>
+              </a:rPr>
+              <a:t>kubectl get pods --show-labels</a:t>
+            </a:r>
+            <a:endParaRPr lang="en-US" sz="1600" dirty="0"/>
+          </a:p>
+          <a:p>
+            <a:pPr indent="0" marL="0">
+              <a:buNone/>
+            </a:pPr>
+            <a:r>
+              <a:rPr lang="en-US" sz="1600" b="1" dirty="0">
+                <a:solidFill>
+                  <a:schemeClr val="accent1"/>
+                </a:solidFill>
+              </a:rPr>
+              <a:t>Fix</a:t>
+            </a:r>
+            <a:endParaRPr lang="en-US" sz="1600" dirty="0"/>
+          </a:p>
+          <a:p>
+            <a:pPr indent="0" marL="0">
+              <a:buNone/>
             </a:pPr>
             <a:r>
               <a:rPr lang="en-US" sz="1600" dirty="0">
@@ -8286,17 +8483,169 @@
                   <a:schemeClr val="tx1"/>
                 </a:solidFill>
               </a:rPr>
-              <a:t>A real load balancer with DNS and TLS.</a:t>
+              <a:t>Patch the Service selector</a:t>
             </a:r>
             <a:endParaRPr lang="en-US" sz="1600" dirty="0"/>
           </a:p>
-          <a:p>
-            <a:pPr marL="228600" indent="-228600">
+        </p:txBody>
+      </p:sp>
+      <p:sp>
+        <p:nvSpPr>
+          <p:cNvPr id="13" name="lab card 3"/>
+          <p:cNvSpPr/>
+          <p:nvPr/>
+        </p:nvSpPr>
+        <p:spPr>
+          <a:xfrm>
+            <a:off x="8046720" y="1463040"/>
+            <a:ext cx="3566160" cy="4023360"/>
+          </a:xfrm>
+          <a:prstGeom prst="roundRect">
+            <a:avLst>
+              <a:gd name="adj" fmla="val 3077"/>
+            </a:avLst>
+          </a:prstGeom>
+          <a:solidFill>
+            <a:schemeClr val="bg2"/>
+          </a:solidFill>
+          <a:ln/>
+        </p:spPr>
+      </p:sp>
+      <p:sp>
+        <p:nvSpPr>
+          <p:cNvPr id="14" name="lab number 3"/>
+          <p:cNvSpPr/>
+          <p:nvPr/>
+        </p:nvSpPr>
+        <p:spPr>
+          <a:xfrm>
+            <a:off x="8275320" y="1691640"/>
+            <a:ext cx="548640" cy="548640"/>
+          </a:xfrm>
+          <a:prstGeom prst="ellipse">
+            <a:avLst/>
+          </a:prstGeom>
+          <a:solidFill>
+            <a:schemeClr val="accent1"/>
+          </a:solidFill>
+          <a:ln/>
+        </p:spPr>
+      </p:sp>
+      <p:sp>
+        <p:nvSpPr>
+          <p:cNvPr id="15" name="lab number text 3"/>
+          <p:cNvSpPr txBox="1"/>
+          <p:nvPr/>
+        </p:nvSpPr>
+        <p:spPr>
+          <a:xfrm>
+            <a:off x="8275320" y="1691640"/>
+            <a:ext cx="548640" cy="548640"/>
+          </a:xfrm>
+          <a:prstGeom prst="rect">
+            <a:avLst/>
+          </a:prstGeom>
+          <a:noFill/>
+          <a:ln/>
+        </p:spPr>
+        <p:txBody>
+          <a:bodyPr wrap="square" lIns="0" tIns="0" rIns="0" bIns="0" rtlCol="0" anchor="ctr"/>
+          <a:lstStyle/>
+          <a:p>
+            <a:pPr algn="ctr" indent="0" marL="0">
+              <a:buNone/>
+            </a:pPr>
+            <a:r>
+              <a:rPr lang="en-US" sz="2000" b="1" dirty="0">
+                <a:solidFill>
+                  <a:schemeClr val="bg1"/>
+                </a:solidFill>
+              </a:rPr>
+              <a:t>3</a:t>
+            </a:r>
+            <a:endParaRPr lang="en-US" sz="2000" dirty="0"/>
+          </a:p>
+        </p:txBody>
+      </p:sp>
+      <p:sp>
+        <p:nvSpPr>
+          <p:cNvPr id="16" name="lab title 3"/>
+          <p:cNvSpPr txBox="1"/>
+          <p:nvPr/>
+        </p:nvSpPr>
+        <p:spPr>
+          <a:xfrm>
+            <a:off x="8961120" y="1645920"/>
+            <a:ext cx="2468880" cy="640080"/>
+          </a:xfrm>
+          <a:prstGeom prst="rect">
+            <a:avLst/>
+          </a:prstGeom>
+          <a:noFill/>
+          <a:ln/>
+        </p:spPr>
+        <p:txBody>
+          <a:bodyPr wrap="square" lIns="0" tIns="0" rIns="0" bIns="0" rtlCol="0" anchor="ctr"/>
+          <a:lstStyle/>
+          <a:p>
+            <a:pPr indent="0" marL="0">
+              <a:buNone/>
+            </a:pPr>
+            <a:r>
+              <a:rPr lang="en-US" sz="2000" b="1" dirty="0">
+                <a:solidFill>
+                  <a:schemeClr val="tx1"/>
+                </a:solidFill>
+                <a:latin typeface="Cambria" pitchFamily="34" charset="0"/>
+                <a:ea typeface="Cambria" pitchFamily="34" charset="-122"/>
+                <a:cs typeface="Cambria" pitchFamily="34" charset="-120"/>
+              </a:rPr>
+              <a:t>Pod never Ready</a:t>
+            </a:r>
+            <a:endParaRPr lang="en-US" sz="2000" dirty="0"/>
+          </a:p>
+        </p:txBody>
+      </p:sp>
+      <p:sp>
+        <p:nvSpPr>
+          <p:cNvPr id="17" name="lab body 3"/>
+          <p:cNvSpPr txBox="1"/>
+          <p:nvPr/>
+        </p:nvSpPr>
+        <p:spPr>
+          <a:xfrm>
+            <a:off x="8275320" y="2514600"/>
+            <a:ext cx="3108960" cy="2834640"/>
+          </a:xfrm>
+          <a:prstGeom prst="rect">
+            <a:avLst/>
+          </a:prstGeom>
+          <a:noFill/>
+          <a:ln/>
+        </p:spPr>
+        <p:txBody>
+          <a:bodyPr wrap="square" lIns="0" tIns="0" rIns="0" bIns="0" rtlCol="0" anchor="t"/>
+          <a:lstStyle/>
+          <a:p>
+            <a:pPr indent="0" marL="0">
+              <a:buNone/>
+            </a:pPr>
+            <a:r>
+              <a:rPr lang="en-US" sz="1600" b="1" dirty="0">
+                <a:solidFill>
+                  <a:schemeClr val="accent1"/>
+                </a:solidFill>
+              </a:rPr>
+              <a:t>Symptom</a:t>
+            </a:r>
+            <a:endParaRPr lang="en-US" sz="1600" dirty="0"/>
+          </a:p>
+          <a:p>
+            <a:pPr indent="0" marL="0">
               <a:spcAft>
-                <a:spcPts val="1000"/>
+                <a:spcPts val="1200"/>
               </a:spcAft>
-              <a:buSzPct val="100000"/>
-              <a:buChar char="•"/>
+              <a:buNone/>
             </a:pPr>
             <a:r>
               <a:rPr lang="en-US" sz="1600" dirty="0">
@@ -8304,17 +8653,81 @@
                   <a:schemeClr val="tx1"/>
                 </a:solidFill>
               </a:rPr>
-              <a:t>Secrets in AWS Secrets Manager.</a:t>
+              <a:t>Wrong readiness path</a:t>
             </a:r>
             <a:endParaRPr lang="en-US" sz="1600" dirty="0"/>
           </a:p>
           <a:p>
-            <a:pPr marL="228600" indent="-228600">
+            <a:pPr indent="0" marL="0">
+              <a:buNone/>
+            </a:pPr>
+            <a:r>
+              <a:rPr lang="en-US" sz="1600" b="1" dirty="0">
+                <a:solidFill>
+                  <a:schemeClr val="accent1"/>
+                </a:solidFill>
+              </a:rPr>
+              <a:t>Diagnose</a:t>
+            </a:r>
+            <a:endParaRPr lang="en-US" sz="1600" dirty="0"/>
+          </a:p>
+          <a:p>
+            <a:pPr indent="0" marL="0">
               <a:spcAft>
-                <a:spcPts val="1000"/>
+                <a:spcPts val="1200"/>
               </a:spcAft>
-              <a:buSzPct val="100000"/>
-              <a:buChar char="•"/>
+              <a:buNone/>
+            </a:pPr>
+            <a:r>
+              <a:rPr lang="en-US" sz="1300" dirty="0">
+                <a:solidFill>
+                  <a:schemeClr val="tx1"/>
+                </a:solidFill>
+                <a:latin typeface="Courier New" pitchFamily="34" charset="0"/>
+                <a:ea typeface="Courier New" pitchFamily="34" charset="-122"/>
+                <a:cs typeface="Courier New" pitchFamily="34" charset="-120"/>
+              </a:rPr>
+              <a:t>kubectl describe pod</a:t>
+            </a:r>
+            <a:endParaRPr lang="en-US" sz="1600" dirty="0"/>
+          </a:p>
+          <a:p>
+            <a:pPr indent="0" marL="0">
+              <a:spcAft>
+                <a:spcPts val="1200"/>
+              </a:spcAft>
+              <a:buNone/>
+            </a:pPr>
+            <a:r>
+              <a:rPr lang="en-US" sz="1300" dirty="0">
+                <a:solidFill>
+                  <a:schemeClr val="tx1"/>
+                </a:solidFill>
+                <a:latin typeface="Courier New" pitchFamily="34" charset="0"/>
+                <a:ea typeface="Courier New" pitchFamily="34" charset="-122"/>
+                <a:cs typeface="Courier New" pitchFamily="34" charset="-120"/>
+              </a:rPr>
+              <a:t>look at probe events</a:t>
+            </a:r>
+            <a:endParaRPr lang="en-US" sz="1600" dirty="0"/>
+          </a:p>
+          <a:p>
+            <a:pPr indent="0" marL="0">
+              <a:buNone/>
+            </a:pPr>
+            <a:r>
+              <a:rPr lang="en-US" sz="1600" b="1" dirty="0">
+                <a:solidFill>
+                  <a:schemeClr val="accent1"/>
+                </a:solidFill>
+              </a:rPr>
+              <a:t>Fix</a:t>
+            </a:r>
+            <a:endParaRPr lang="en-US" sz="1600" dirty="0"/>
+          </a:p>
+          <a:p>
+            <a:pPr indent="0" marL="0">
+              <a:buNone/>
             </a:pPr>
             <a:r>
               <a:rPr lang="en-US" sz="1600" dirty="0">
@@ -8322,25 +8735,7 @@
                   <a:schemeClr val="tx1"/>
                 </a:solidFill>
               </a:rPr>
-              <a:t>OIDC-based credentials so the pipeline can deploy without stored secrets.</a:t>
-            </a:r>
-            <a:endParaRPr lang="en-US" sz="1600" dirty="0"/>
-          </a:p>
-          <a:p>
-            <a:pPr marL="228600" indent="-228600">
-              <a:spcAft>
-                <a:spcPts val="1000"/>
-              </a:spcAft>
-              <a:buSzPct val="100000"/>
-              <a:buChar char="•"/>
-            </a:pPr>
-            <a:r>
-              <a:rPr lang="en-US" sz="1600" dirty="0">
-                <a:solidFill>
-                  <a:schemeClr val="tx1"/>
-                </a:solidFill>
-              </a:rPr>
-              <a:t>Alert rules for error rate and latency.</a:t>
+              <a:t>Fix the probe path</a:t>
             </a:r>
             <a:endParaRPr lang="en-US" sz="1600" dirty="0"/>
           </a:p>
@@ -8421,6 +8816,368 @@
       </p:grpSpPr>
       <p:sp>
         <p:nvSpPr>
+          <p:cNvPr id="2" name="Text 1"/>
+          <p:cNvSpPr/>
+          <p:nvPr>
+            <p:ph idx="101" type="title" hasCustomPrompt="1"/>
+          </p:nvPr>
+        </p:nvSpPr>
+        <p:spPr>
+          <a:xfrm>
+            <a:off x="548640" y="365760"/>
+            <a:ext cx="8595360" cy="822960"/>
+          </a:xfrm>
+          <a:prstGeom prst="rect">
+            <a:avLst/>
+          </a:prstGeom>
+          <a:noFill/>
+          <a:ln/>
+        </p:spPr>
+        <p:txBody>
+          <a:bodyPr wrap="square" lIns="0" tIns="0" rIns="0" bIns="0" rtlCol="0" anchor="ctr"/>
+          <a:lstStyle/>
+          <a:p>
+            <a:pPr algn="l" indent="0" marL="0">
+              <a:buNone/>
+            </a:pPr>
+            <a:r>
+              <a:rPr lang="en-US" sz="3400" b="1" dirty="0">
+                <a:solidFill>
+                  <a:schemeClr val="tx1"/>
+                </a:solidFill>
+                <a:latin typeface="Cambria" pitchFamily="34" charset="0"/>
+                <a:ea typeface="Cambria" pitchFamily="34" charset="-122"/>
+                <a:cs typeface="Cambria" pitchFamily="34" charset="-120"/>
+              </a:rPr>
+              <a:t>Limits and next steps</a:t>
+            </a:r>
+            <a:endParaRPr lang="en-US" sz="3400" dirty="0"/>
+          </a:p>
+        </p:txBody>
+      </p:sp>
+      <p:sp>
+        <p:nvSpPr>
+          <p:cNvPr id="3" name="limits heading"/>
+          <p:cNvSpPr txBox="1"/>
+          <p:nvPr/>
+        </p:nvSpPr>
+        <p:spPr>
+          <a:xfrm>
+            <a:off x="548640" y="1417320"/>
+            <a:ext cx="5303520" cy="457200"/>
+          </a:xfrm>
+          <a:prstGeom prst="rect">
+            <a:avLst/>
+          </a:prstGeom>
+          <a:noFill/>
+          <a:ln/>
+        </p:spPr>
+        <p:txBody>
+          <a:bodyPr wrap="square" lIns="0" tIns="0" rIns="0" bIns="0" rtlCol="0" anchor="ctr"/>
+          <a:lstStyle/>
+          <a:p>
+            <a:pPr indent="0" marL="0">
+              <a:buNone/>
+            </a:pPr>
+            <a:r>
+              <a:rPr lang="en-US" sz="2400" b="1" dirty="0">
+                <a:solidFill>
+                  <a:schemeClr val="accent4"/>
+                </a:solidFill>
+                <a:latin typeface="Cambria" pitchFamily="34" charset="0"/>
+                <a:ea typeface="Cambria" pitchFamily="34" charset="-122"/>
+                <a:cs typeface="Cambria" pitchFamily="34" charset="-120"/>
+              </a:rPr>
+              <a:t>Known limits</a:t>
+            </a:r>
+            <a:endParaRPr lang="en-US" sz="2400" dirty="0"/>
+          </a:p>
+        </p:txBody>
+      </p:sp>
+      <p:sp>
+        <p:nvSpPr>
+          <p:cNvPr id="4" name="bullets"/>
+          <p:cNvSpPr txBox="1"/>
+          <p:nvPr/>
+        </p:nvSpPr>
+        <p:spPr>
+          <a:xfrm>
+            <a:off x="548640" y="1965960"/>
+            <a:ext cx="5303520" cy="4023360"/>
+          </a:xfrm>
+          <a:prstGeom prst="rect">
+            <a:avLst/>
+          </a:prstGeom>
+          <a:noFill/>
+          <a:ln/>
+        </p:spPr>
+        <p:txBody>
+          <a:bodyPr wrap="square" lIns="0" tIns="0" rIns="0" bIns="0" rtlCol="0" anchor="t"/>
+          <a:lstStyle/>
+          <a:p>
+            <a:pPr marL="228600" indent="-228600">
+              <a:spcAft>
+                <a:spcPts val="1000"/>
+              </a:spcAft>
+              <a:buSzPct val="100000"/>
+              <a:buChar char="•"/>
+            </a:pPr>
+            <a:r>
+              <a:rPr lang="en-US" sz="1600" dirty="0">
+                <a:solidFill>
+                  <a:schemeClr val="tx1"/>
+                </a:solidFill>
+              </a:rPr>
+              <a:t>The AWS account cannot create load balancers, so the Ingress is reached by port-forward.</a:t>
+            </a:r>
+            <a:endParaRPr lang="en-US" sz="1600" dirty="0"/>
+          </a:p>
+          <a:p>
+            <a:pPr marL="228600" indent="-228600">
+              <a:spcAft>
+                <a:spcPts val="1000"/>
+              </a:spcAft>
+              <a:buSzPct val="100000"/>
+              <a:buChar char="•"/>
+            </a:pPr>
+            <a:r>
+              <a:rPr lang="en-US" sz="1600" dirty="0">
+                <a:solidFill>
+                  <a:schemeClr val="tx1"/>
+                </a:solidFill>
+              </a:rPr>
+              <a:t>PostgreSQL runs inside the cluster for a self-contained capstone.</a:t>
+            </a:r>
+            <a:endParaRPr lang="en-US" sz="1600" dirty="0"/>
+          </a:p>
+        </p:txBody>
+      </p:sp>
+      <p:sp>
+        <p:nvSpPr>
+          <p:cNvPr id="5" name="next heading"/>
+          <p:cNvSpPr txBox="1"/>
+          <p:nvPr/>
+        </p:nvSpPr>
+        <p:spPr>
+          <a:xfrm>
+            <a:off x="6400800" y="1417320"/>
+            <a:ext cx="5212080" cy="457200"/>
+          </a:xfrm>
+          <a:prstGeom prst="rect">
+            <a:avLst/>
+          </a:prstGeom>
+          <a:noFill/>
+          <a:ln/>
+        </p:spPr>
+        <p:txBody>
+          <a:bodyPr wrap="square" lIns="0" tIns="0" rIns="0" bIns="0" rtlCol="0" anchor="ctr"/>
+          <a:lstStyle/>
+          <a:p>
+            <a:pPr indent="0" marL="0">
+              <a:buNone/>
+            </a:pPr>
+            <a:r>
+              <a:rPr lang="en-US" sz="2400" b="1" dirty="0">
+                <a:solidFill>
+                  <a:schemeClr val="accent1"/>
+                </a:solidFill>
+                <a:latin typeface="Cambria" pitchFamily="34" charset="0"/>
+                <a:ea typeface="Cambria" pitchFamily="34" charset="-122"/>
+                <a:cs typeface="Cambria" pitchFamily="34" charset="-120"/>
+              </a:rPr>
+              <a:t>What I would do next</a:t>
+            </a:r>
+            <a:endParaRPr lang="en-US" sz="2400" dirty="0"/>
+          </a:p>
+        </p:txBody>
+      </p:sp>
+      <p:sp>
+        <p:nvSpPr>
+          <p:cNvPr id="6" name="bullets"/>
+          <p:cNvSpPr txBox="1"/>
+          <p:nvPr/>
+        </p:nvSpPr>
+        <p:spPr>
+          <a:xfrm>
+            <a:off x="6400800" y="1965960"/>
+            <a:ext cx="5212080" cy="4023360"/>
+          </a:xfrm>
+          <a:prstGeom prst="rect">
+            <a:avLst/>
+          </a:prstGeom>
+          <a:noFill/>
+          <a:ln/>
+        </p:spPr>
+        <p:txBody>
+          <a:bodyPr wrap="square" lIns="0" tIns="0" rIns="0" bIns="0" rtlCol="0" anchor="t"/>
+          <a:lstStyle/>
+          <a:p>
+            <a:pPr marL="228600" indent="-228600">
+              <a:spcAft>
+                <a:spcPts val="1000"/>
+              </a:spcAft>
+              <a:buSzPct val="100000"/>
+              <a:buChar char="•"/>
+            </a:pPr>
+            <a:r>
+              <a:rPr lang="en-US" sz="1600" dirty="0">
+                <a:solidFill>
+                  <a:schemeClr val="tx1"/>
+                </a:solidFill>
+              </a:rPr>
+              <a:t>Amazon RDS for backups and Multi-AZ failover.</a:t>
+            </a:r>
+            <a:endParaRPr lang="en-US" sz="1600" dirty="0"/>
+          </a:p>
+          <a:p>
+            <a:pPr marL="228600" indent="-228600">
+              <a:spcAft>
+                <a:spcPts val="1000"/>
+              </a:spcAft>
+              <a:buSzPct val="100000"/>
+              <a:buChar char="•"/>
+            </a:pPr>
+            <a:r>
+              <a:rPr lang="en-US" sz="1600" dirty="0">
+                <a:solidFill>
+                  <a:schemeClr val="tx1"/>
+                </a:solidFill>
+              </a:rPr>
+              <a:t>A real load balancer with DNS and TLS.</a:t>
+            </a:r>
+            <a:endParaRPr lang="en-US" sz="1600" dirty="0"/>
+          </a:p>
+          <a:p>
+            <a:pPr marL="228600" indent="-228600">
+              <a:spcAft>
+                <a:spcPts val="1000"/>
+              </a:spcAft>
+              <a:buSzPct val="100000"/>
+              <a:buChar char="•"/>
+            </a:pPr>
+            <a:r>
+              <a:rPr lang="en-US" sz="1600" dirty="0">
+                <a:solidFill>
+                  <a:schemeClr val="tx1"/>
+                </a:solidFill>
+              </a:rPr>
+              <a:t>Secrets in AWS Secrets Manager.</a:t>
+            </a:r>
+            <a:endParaRPr lang="en-US" sz="1600" dirty="0"/>
+          </a:p>
+          <a:p>
+            <a:pPr marL="228600" indent="-228600">
+              <a:spcAft>
+                <a:spcPts val="1000"/>
+              </a:spcAft>
+              <a:buSzPct val="100000"/>
+              <a:buChar char="•"/>
+            </a:pPr>
+            <a:r>
+              <a:rPr lang="en-US" sz="1600" dirty="0">
+                <a:solidFill>
+                  <a:schemeClr val="tx1"/>
+                </a:solidFill>
+              </a:rPr>
+              <a:t>OIDC-based credentials so the pipeline can deploy without stored secrets.</a:t>
+            </a:r>
+            <a:endParaRPr lang="en-US" sz="1600" dirty="0"/>
+          </a:p>
+          <a:p>
+            <a:pPr marL="228600" indent="-228600">
+              <a:spcAft>
+                <a:spcPts val="1000"/>
+              </a:spcAft>
+              <a:buSzPct val="100000"/>
+              <a:buChar char="•"/>
+            </a:pPr>
+            <a:r>
+              <a:rPr lang="en-US" sz="1600" dirty="0">
+                <a:solidFill>
+                  <a:schemeClr val="tx1"/>
+                </a:solidFill>
+              </a:rPr>
+              <a:t>Alert rules for error rate and latency.</a:t>
+            </a:r>
+            <a:endParaRPr lang="en-US" sz="1600" dirty="0"/>
+          </a:p>
+        </p:txBody>
+      </p:sp>
+      <p:sp>
+        <p:nvSpPr>
+          <p:cNvPr id="25" name="Slide Number Placeholder 0"/>
+          <p:cNvSpPr>
+            <a:spLocks noGrp="1"/>
+          </p:cNvSpPr>
+          <p:nvPr>
+            <p:ph type="sldNum" sz="quarter" idx="4294967295"/>
+          </p:nvPr>
+        </p:nvSpPr>
+        <p:spPr>
+          <a:xfrm>
+            <a:off x="11155680" y="6400800"/>
+            <a:ext cx="548640" cy="274320"/>
+          </a:xfrm>
+          <a:prstGeom prst="rect">
+            <a:avLst/>
+          </a:prstGeom>
+          <a:extLst>
+            <a:ext uri="{C572A759-6A51-4108-AA02-DFA0A04FC94B}">
+              <ma14:wrappingTextBoxFlag xmlns:ma14="http://schemas.microsoft.com/office/mac/drawingml/2011/main" val="0"/>
+            </a:ext>
+          </a:extLst>
+        </p:spPr>
+        <p:txBody>
+          <a:bodyPr/>
+          <a:lstStyle>
+            <a:lvl1pPr>
+              <a:defRPr sz="1100">
+                <a:solidFill>
+                  <a:srgbClr val="64748B"/>
+                </a:solidFill>
+                <a:latin typeface="Calibri"/>
+                <a:ea typeface="Calibri"/>
+                <a:cs typeface="Calibri"/>
+              </a:defRPr>
+            </a:lvl1pPr>
+          </a:lstStyle>
+          <a:p>
+            <a:pPr algn="r"/>
+            <a:fld id="{F7021451-1387-4CA6-816F-3879F97B5CBC}" type="slidenum">
+              <a:rPr b="0" lang="en-US"/>
+              <a:t>18</a:t>
+            </a:fld>
+            <a:endParaRPr lang="en-US"/>
+          </a:p>
+        </p:txBody>
+      </p:sp>
+    </p:spTree>
+  </p:cSld>
+  <p:clrMapOvr>
+    <a:masterClrMapping/>
+  </p:clrMapOvr>
+</p:sld>
+</file>
+
+<file path=ppt/slides/slide19.xml><?xml version="1.0" encoding="utf-8"?>
+<p:sld xmlns:a="http://schemas.openxmlformats.org/drawingml/2006/main" xmlns:r="http://schemas.openxmlformats.org/officeDocument/2006/relationships" xmlns:p="http://schemas.openxmlformats.org/presentationml/2006/main">
+  <p:cSld name="Slide 19">
+    <p:spTree>
+      <p:nvGrpSpPr>
+        <p:cNvPr id="1" name=""/>
+        <p:cNvGrpSpPr/>
+        <p:nvPr/>
+      </p:nvGrpSpPr>
+      <p:grpSpPr>
+        <a:xfrm>
+          <a:off x="0" y="0"/>
+          <a:ext cx="0" cy="0"/>
+          <a:chOff x="0" y="0"/>
+          <a:chExt cx="0" cy="0"/>
+        </a:xfrm>
+      </p:grpSpPr>
+      <p:sp>
+        <p:nvSpPr>
           <p:cNvPr id="2" name="closing title"/>
           <p:cNvSpPr txBox="1"/>
           <p:nvPr/>
@@ -9312,7 +10069,7 @@
             <a:pPr algn="r"/>
             <a:fld id="{F7021451-1387-4CA6-816F-3879F97B5CBC}" type="slidenum">
               <a:rPr b="0" lang="en-US"/>
-              <a:t>18</a:t>
+              <a:t>19</a:t>
             </a:fld>
             <a:endParaRPr lang="en-US"/>
           </a:p>
@@ -9516,7 +10273,7 @@
                   <a:schemeClr val="tx1"/>
                 </a:solidFill>
               </a:rPr>
-              <a:t> Docker, GitHub Actions, Trivy, GHCR, Terraform, EKS, Helm, Prometheus and Grafana.</a:t>
+              <a:t> Docker, GitHub Actions, Trivy, GHCR, Terraform, EKS, Helm, ArgoCD, Prometheus and Grafana.</a:t>
             </a:r>
             <a:endParaRPr lang="en-US" sz="1800" dirty="0"/>
           </a:p>
@@ -10363,7 +11120,7 @@
                   <a:schemeClr val="accent6"/>
                 </a:solidFill>
               </a:rPr>
-              <a:t>test, build, scan</a:t>
+              <a:t>test, build, scan, tag</a:t>
             </a:r>
             <a:endParaRPr lang="en-US" sz="1200" dirty="0"/>
           </a:p>
@@ -10518,7 +11275,7 @@
       </p:sp>
       <p:sp>
         <p:nvSpPr>
-          <p:cNvPr id="19" name="box Helm"/>
+          <p:cNvPr id="19" name="box ArgoCD"/>
           <p:cNvSpPr/>
           <p:nvPr/>
         </p:nvSpPr>
@@ -10545,7 +11302,7 @@
       </p:sp>
       <p:sp>
         <p:nvSpPr>
-          <p:cNvPr id="20" name="box text Helm"/>
+          <p:cNvPr id="20" name="box text ArgoCD"/>
           <p:cNvSpPr txBox="1"/>
           <p:nvPr/>
         </p:nvSpPr>
@@ -10573,7 +11330,7 @@
                   <a:schemeClr val="bg1"/>
                 </a:solidFill>
               </a:rPr>
-              <a:t>Helm</a:t>
+              <a:t>ArgoCD</a:t>
             </a:r>
             <a:endParaRPr lang="en-US" sz="1400" dirty="0"/>
           </a:p>
@@ -10581,7 +11338,7 @@
       </p:sp>
       <p:sp>
         <p:nvSpPr>
-          <p:cNvPr id="21" name="caption Helm"/>
+          <p:cNvPr id="21" name="caption ArgoCD"/>
           <p:cNvSpPr txBox="1"/>
           <p:nvPr/>
         </p:nvSpPr>
@@ -10609,7 +11366,7 @@
                   <a:schemeClr val="accent6"/>
                 </a:solidFill>
               </a:rPr>
-              <a:t>upgrade --install</a:t>
+              <a:t>syncs from Git</a:t>
             </a:r>
             <a:endParaRPr lang="en-US" sz="1200" dirty="0"/>
           </a:p>
@@ -13407,7 +14164,7 @@
         <p:spPr>
           <a:xfrm>
             <a:off x="548640" y="1417320"/>
-            <a:ext cx="2011680" cy="640080"/>
+            <a:ext cx="1783080" cy="640080"/>
           </a:xfrm>
           <a:prstGeom prst="chevron">
             <a:avLst/>
@@ -13427,7 +14184,7 @@
         <p:spPr>
           <a:xfrm>
             <a:off x="777240" y="1417320"/>
-            <a:ext cx="1554480" cy="640080"/>
+            <a:ext cx="1325880" cy="640080"/>
           </a:xfrm>
           <a:prstGeom prst="rect">
             <a:avLst/>
@@ -13443,14 +14200,14 @@
               <a:buNone/>
             </a:pPr>
             <a:r>
-              <a:rPr lang="en-US" sz="1300" b="1" dirty="0">
+              <a:rPr lang="en-US" sz="1200" b="1" dirty="0">
                 <a:solidFill>
                   <a:schemeClr val="bg1"/>
                 </a:solidFill>
               </a:rPr>
               <a:t>pytest</a:t>
             </a:r>
-            <a:endParaRPr lang="en-US" sz="1300" dirty="0"/>
+            <a:endParaRPr lang="en-US" sz="1200" dirty="0"/>
           </a:p>
         </p:txBody>
       </p:sp>
@@ -13462,8 +14219,8 @@
         </p:nvSpPr>
         <p:spPr>
           <a:xfrm>
-            <a:off x="2788920" y="1417320"/>
-            <a:ext cx="2011680" cy="640080"/>
+            <a:off x="2404872" y="1417320"/>
+            <a:ext cx="1783080" cy="640080"/>
           </a:xfrm>
           <a:prstGeom prst="chevron">
             <a:avLst/>
@@ -13482,8 +14239,8 @@
         </p:nvSpPr>
         <p:spPr>
           <a:xfrm>
-            <a:off x="3017520" y="1417320"/>
-            <a:ext cx="1554480" cy="640080"/>
+            <a:off x="2633472" y="1417320"/>
+            <a:ext cx="1325880" cy="640080"/>
           </a:xfrm>
           <a:prstGeom prst="rect">
             <a:avLst/>
@@ -13499,14 +14256,14 @@
               <a:buNone/>
             </a:pPr>
             <a:r>
-              <a:rPr lang="en-US" sz="1300" b="1" dirty="0">
+              <a:rPr lang="en-US" sz="1200" b="1" dirty="0">
                 <a:solidFill>
                   <a:schemeClr val="bg1"/>
                 </a:solidFill>
               </a:rPr>
               <a:t>Frontend build</a:t>
             </a:r>
-            <a:endParaRPr lang="en-US" sz="1300" dirty="0"/>
+            <a:endParaRPr lang="en-US" sz="1200" dirty="0"/>
           </a:p>
         </p:txBody>
       </p:sp>
@@ -13518,8 +14275,8 @@
         </p:nvSpPr>
         <p:spPr>
           <a:xfrm>
-            <a:off x="5029200" y="1417320"/>
-            <a:ext cx="2011680" cy="640080"/>
+            <a:off x="4261104" y="1417320"/>
+            <a:ext cx="1783080" cy="640080"/>
           </a:xfrm>
           <a:prstGeom prst="chevron">
             <a:avLst/>
@@ -13538,8 +14295,8 @@
         </p:nvSpPr>
         <p:spPr>
           <a:xfrm>
-            <a:off x="5257800" y="1417320"/>
-            <a:ext cx="1554480" cy="640080"/>
+            <a:off x="4489704" y="1417320"/>
+            <a:ext cx="1325880" cy="640080"/>
           </a:xfrm>
           <a:prstGeom prst="rect">
             <a:avLst/>
@@ -13555,14 +14312,14 @@
               <a:buNone/>
             </a:pPr>
             <a:r>
-              <a:rPr lang="en-US" sz="1300" b="1" dirty="0">
+              <a:rPr lang="en-US" sz="1200" b="1" dirty="0">
                 <a:solidFill>
                   <a:schemeClr val="bg1"/>
                 </a:solidFill>
               </a:rPr>
               <a:t>Docker build x2</a:t>
             </a:r>
-            <a:endParaRPr lang="en-US" sz="1300" dirty="0"/>
+            <a:endParaRPr lang="en-US" sz="1200" dirty="0"/>
           </a:p>
         </p:txBody>
       </p:sp>
@@ -13574,8 +14331,8 @@
         </p:nvSpPr>
         <p:spPr>
           <a:xfrm>
-            <a:off x="7269480" y="1417320"/>
-            <a:ext cx="2011680" cy="640080"/>
+            <a:off x="6117336" y="1417320"/>
+            <a:ext cx="1783080" cy="640080"/>
           </a:xfrm>
           <a:prstGeom prst="chevron">
             <a:avLst/>
@@ -13594,8 +14351,8 @@
         </p:nvSpPr>
         <p:spPr>
           <a:xfrm>
-            <a:off x="7498080" y="1417320"/>
-            <a:ext cx="1554480" cy="640080"/>
+            <a:off x="6345936" y="1417320"/>
+            <a:ext cx="1325880" cy="640080"/>
           </a:xfrm>
           <a:prstGeom prst="rect">
             <a:avLst/>
@@ -13611,14 +14368,14 @@
               <a:buNone/>
             </a:pPr>
             <a:r>
-              <a:rPr lang="en-US" sz="1300" b="1" dirty="0">
+              <a:rPr lang="en-US" sz="1200" b="1" dirty="0">
                 <a:solidFill>
                   <a:schemeClr val="tx1"/>
                 </a:solidFill>
               </a:rPr>
               <a:t>Trivy scan x2</a:t>
             </a:r>
-            <a:endParaRPr lang="en-US" sz="1300" dirty="0"/>
+            <a:endParaRPr lang="en-US" sz="1200" dirty="0"/>
           </a:p>
         </p:txBody>
       </p:sp>
@@ -13630,8 +14387,8 @@
         </p:nvSpPr>
         <p:spPr>
           <a:xfrm>
-            <a:off x="9509760" y="1417320"/>
-            <a:ext cx="2011680" cy="640080"/>
+            <a:off x="7973568" y="1417320"/>
+            <a:ext cx="1783080" cy="640080"/>
           </a:xfrm>
           <a:prstGeom prst="chevron">
             <a:avLst/>
@@ -13650,8 +14407,8 @@
         </p:nvSpPr>
         <p:spPr>
           <a:xfrm>
-            <a:off x="9738360" y="1417320"/>
-            <a:ext cx="1554480" cy="640080"/>
+            <a:off x="8202168" y="1417320"/>
+            <a:ext cx="1325880" cy="640080"/>
           </a:xfrm>
           <a:prstGeom prst="rect">
             <a:avLst/>
@@ -13667,20 +14424,76 @@
               <a:buNone/>
             </a:pPr>
             <a:r>
-              <a:rPr lang="en-US" sz="1300" b="1" dirty="0">
+              <a:rPr lang="en-US" sz="1200" b="1" dirty="0">
                 <a:solidFill>
                   <a:schemeClr val="bg1"/>
                 </a:solidFill>
               </a:rPr>
               <a:t>Push to GHCR</a:t>
             </a:r>
-            <a:endParaRPr lang="en-US" sz="1300" dirty="0"/>
+            <a:endParaRPr lang="en-US" sz="1200" dirty="0"/>
+          </a:p>
+        </p:txBody>
+      </p:sp>
+      <p:sp>
+        <p:nvSpPr>
+          <p:cNvPr id="15" name="stage Commit tag to Git"/>
+          <p:cNvSpPr/>
+          <p:nvPr/>
+        </p:nvSpPr>
+        <p:spPr>
+          <a:xfrm>
+            <a:off x="9829800" y="1417320"/>
+            <a:ext cx="1783080" cy="640080"/>
+          </a:xfrm>
+          <a:prstGeom prst="chevron">
+            <a:avLst/>
+          </a:prstGeom>
+          <a:solidFill>
+            <a:schemeClr val="accent1"/>
+          </a:solidFill>
+          <a:ln/>
+        </p:spPr>
+      </p:sp>
+      <p:sp>
+        <p:nvSpPr>
+          <p:cNvPr id="16" name="stage text Commit tag to Git"/>
+          <p:cNvSpPr txBox="1"/>
+          <p:nvPr/>
+        </p:nvSpPr>
+        <p:spPr>
+          <a:xfrm>
+            <a:off x="10058400" y="1417320"/>
+            <a:ext cx="1325880" cy="640080"/>
+          </a:xfrm>
+          <a:prstGeom prst="rect">
+            <a:avLst/>
+          </a:prstGeom>
+          <a:noFill/>
+          <a:ln/>
+        </p:spPr>
+        <p:txBody>
+          <a:bodyPr wrap="square" lIns="0" tIns="0" rIns="0" bIns="0" rtlCol="0" anchor="ctr"/>
+          <a:lstStyle/>
+          <a:p>
+            <a:pPr algn="ctr" indent="0" marL="0">
+              <a:buNone/>
+            </a:pPr>
+            <a:r>
+              <a:rPr lang="en-US" sz="1200" b="1" dirty="0">
+                <a:solidFill>
+                  <a:schemeClr val="bg1"/>
+                </a:solidFill>
+              </a:rPr>
+              <a:t>Commit tag to Git</a:t>
+            </a:r>
+            <a:endParaRPr lang="en-US" sz="1200" dirty="0"/>
           </a:p>
         </p:txBody>
       </p:sp>
       <p:pic>
         <p:nvPicPr>
-          <p:cNvPr id="15" name="actions run" descr="Green run: all three jobs">    </p:cNvPr>
+          <p:cNvPr id="17" name="actions run" descr="Green run: all three jobs">    </p:cNvPr>
           <p:cNvPicPr>
             <a:picLocks noChangeAspect="1"/>
           </p:cNvPicPr>
@@ -13694,8 +14507,8 @@
         </p:blipFill>
         <p:spPr>
           <a:xfrm>
-            <a:off x="548640" y="2707720"/>
-            <a:ext cx="5486400" cy="2356960"/>
+            <a:off x="548640" y="2423160"/>
+            <a:ext cx="5486400" cy="2926080"/>
           </a:xfrm>
           <a:prstGeom prst="rect">
             <a:avLst/>
@@ -13711,14 +14524,14 @@
       </p:pic>
       <p:sp>
         <p:nvSpPr>
-          <p:cNvPr id="16" name="actions run border"/>
+          <p:cNvPr id="18" name="actions run border"/>
           <p:cNvSpPr/>
           <p:nvPr/>
         </p:nvSpPr>
         <p:spPr>
           <a:xfrm>
-            <a:off x="548640" y="2707720"/>
-            <a:ext cx="5486400" cy="2356960"/>
+            <a:off x="548640" y="2423160"/>
+            <a:ext cx="5486400" cy="2926080"/>
           </a:xfrm>
           <a:prstGeom prst="rect">
             <a:avLst/>
@@ -13733,13 +14546,13 @@
       </p:sp>
       <p:sp>
         <p:nvSpPr>
-          <p:cNvPr id="17" name="actions run caption"/>
+          <p:cNvPr id="19" name="actions run caption"/>
           <p:cNvSpPr txBox="1"/>
           <p:nvPr/>
         </p:nvSpPr>
         <p:spPr>
           <a:xfrm>
-            <a:off x="548640" y="5110400"/>
+            <a:off x="548640" y="5394960"/>
             <a:ext cx="5486400" cy="274320"/>
           </a:xfrm>
           <a:prstGeom prst="rect">
@@ -13769,7 +14582,7 @@
       </p:sp>
       <p:pic>
         <p:nvPicPr>
-          <p:cNvPr id="18" name="ghcr package" descr="GHCR images tagged with the commit SHA">    </p:cNvPr>
+          <p:cNvPr id="20" name="ghcr package" descr="GHCR images tagged with the commit SHA">    </p:cNvPr>
           <p:cNvPicPr>
             <a:picLocks noChangeAspect="1"/>
           </p:cNvPicPr>
@@ -13800,7 +14613,7 @@
       </p:pic>
       <p:sp>
         <p:nvSpPr>
-          <p:cNvPr id="19" name="ghcr package border"/>
+          <p:cNvPr id="21" name="ghcr package border"/>
           <p:cNvSpPr/>
           <p:nvPr/>
         </p:nvSpPr>
@@ -13822,7 +14635,7 @@
       </p:sp>
       <p:sp>
         <p:nvSpPr>
-          <p:cNvPr id="20" name="ghcr package caption"/>
+          <p:cNvPr id="22" name="ghcr package caption"/>
           <p:cNvSpPr txBox="1"/>
           <p:nvPr/>
         </p:nvSpPr>
@@ -13858,7 +14671,7 @@
       </p:sp>
       <p:sp>
         <p:nvSpPr>
-          <p:cNvPr id="21" name="pipeline note"/>
+          <p:cNvPr id="23" name="pipeline note"/>
           <p:cNvSpPr txBox="1"/>
           <p:nvPr/>
         </p:nvSpPr>
@@ -13886,7 +14699,7 @@
                   <a:schemeClr val="tx1"/>
                 </a:solidFill>
               </a:rPr>
-              <a:t>Triggers on every push to main. Nothing is pushed unless tests and both scans pass; tags are commit SHAs, never latest.</a:t>
+              <a:t>Runs on every push to main. Nothing is pushed unless tests and both scans pass; tags are commit SHAs, and the last step commits the new tag to Git for ArgoCD.</a:t>
             </a:r>
             <a:endParaRPr lang="en-US" sz="1500" dirty="0"/>
           </a:p>

</xml_diff>